<commit_message>
docs: add comprehensive final report (docx & md) and expanded 12-slide presentation deck
</commit_message>
<xml_diff>
--- a/PreAuthorisation_Desk_Presentation.pptx
+++ b/PreAuthorisation_Desk_Presentation.pptx
@@ -15,6 +15,8 @@
     <p:sldId id="263" r:id="rId14"/>
     <p:sldId id="264" r:id="rId15"/>
     <p:sldId id="265" r:id="rId16"/>
+    <p:sldId id="266" r:id="rId17"/>
+    <p:sldId id="267" r:id="rId18"/>
   </p:sldIdLst>
   <p:sldSz cx="12191695" cy="6858000" type="screen4x3"/>
   <p:notesSz cx="6858000" cy="9144000"/>
@@ -3145,8 +3147,8 @@
         </p:nvSpPr>
         <p:spPr>
           <a:xfrm>
-            <a:off x="1097280" y="1645920"/>
-            <a:ext cx="10058400" cy="3657600"/>
+            <a:off x="914400" y="1463040"/>
+            <a:ext cx="10332720" cy="4114800"/>
           </a:xfrm>
           <a:prstGeom prst="rect">
             <a:avLst/>
@@ -3161,24 +3163,24 @@
           <a:p>
             <a:pPr>
               <a:spcAft>
+                <a:spcPts val="1200"/>
+              </a:spcAft>
+              <a:defRPr sz="1600">
+                <a:solidFill>
+                  <a:srgbClr val="93C5FD"/>
+                </a:solidFill>
+              </a:defRPr>
+            </a:pPr>
+            <a:r>
+              <a:t>UE24AM342AA5 — ML System Design &amp; AgentOps</a:t>
+            </a:r>
+          </a:p>
+          <a:p>
+            <a:pPr>
+              <a:spcAft>
                 <a:spcPts val="1400"/>
               </a:spcAft>
-              <a:defRPr sz="1600">
-                <a:solidFill>
-                  <a:srgbClr val="93C5FD"/>
-                </a:solidFill>
-              </a:defRPr>
-            </a:pPr>
-            <a:r>
-              <a:t>UE24AM342AA5 — ML System Design &amp; AgentOps</a:t>
-            </a:r>
-          </a:p>
-          <a:p>
-            <a:pPr>
-              <a:spcAft>
-                <a:spcPts val="1600"/>
-              </a:spcAft>
-              <a:defRPr sz="3600" b="1">
+              <a:defRPr sz="3400" b="1">
                 <a:solidFill>
                   <a:srgbClr val="FFFFFF"/>
                 </a:solidFill>
@@ -3191,9 +3193,9 @@
           <a:p>
             <a:pPr>
               <a:spcAft>
-                <a:spcPts val="3200"/>
-              </a:spcAft>
-              <a:defRPr sz="1800">
+                <a:spcPts val="2800"/>
+              </a:spcAft>
+              <a:defRPr sz="1700">
                 <a:solidFill>
                   <a:srgbClr val="E2E8F0"/>
                 </a:solidFill>
@@ -3205,12 +3207,16 @@
           </a:p>
           <a:p>
             <a:pPr>
-              <a:defRPr sz="1400">
+              <a:defRPr sz="1300">
                 <a:solidFill>
                   <a:srgbClr val="BFDBFE"/>
                 </a:solidFill>
               </a:defRPr>
             </a:pPr>
+            <a:r>
+              <a:t>Student: Dharshini V (SRN: PES1UG24AM428) &amp; Team  |  Component: Jackfruit (Level 3, 10 Marks)</a:t>
+            </a:r>
+            <a:br/>
             <a:r>
               <a:t>Department of Computer Science &amp; Engineering (AI &amp; ML) | PES University</a:t>
             </a:r>
@@ -3243,8 +3249,8 @@
         </p:nvSpPr>
         <p:spPr>
           <a:xfrm>
-            <a:off x="731520" y="457200"/>
-            <a:ext cx="10515600" cy="365760"/>
+            <a:off x="731520" y="411480"/>
+            <a:ext cx="10515600" cy="320040"/>
           </a:xfrm>
           <a:prstGeom prst="rect">
             <a:avLst/>
@@ -3278,7 +3284,7 @@
         </p:nvSpPr>
         <p:spPr>
           <a:xfrm>
-            <a:off x="731520" y="777240"/>
+            <a:off x="731520" y="685800"/>
             <a:ext cx="10515600" cy="640080"/>
           </a:xfrm>
           <a:prstGeom prst="rect">
@@ -3293,14 +3299,14 @@
           <a:lstStyle/>
           <a:p>
             <a:pPr>
-              <a:defRPr sz="2400" b="1">
+              <a:defRPr sz="2300" b="1">
                 <a:solidFill>
                   <a:srgbClr val="1E3A8A"/>
                 </a:solidFill>
               </a:defRPr>
             </a:pPr>
             <a:r>
-              <a:t>Summary, Design Judgement &amp; Repository</a:t>
+              <a:t>Container Architecture &amp; Worker Scaling (D3, A7)</a:t>
             </a:r>
           </a:p>
         </p:txBody>
@@ -3313,8 +3319,8 @@
         </p:nvSpPr>
         <p:spPr>
           <a:xfrm>
-            <a:off x="731520" y="1645920"/>
-            <a:ext cx="5120640" cy="4572000"/>
+            <a:off x="731520" y="1508760"/>
+            <a:ext cx="5120640" cy="4846320"/>
           </a:xfrm>
           <a:prstGeom prst="roundRect">
             <a:avLst/>
@@ -3358,8 +3364,8 @@
         </p:nvSpPr>
         <p:spPr>
           <a:xfrm>
-            <a:off x="914400" y="1828800"/>
-            <a:ext cx="4754880" cy="4206240"/>
+            <a:off x="914400" y="1673352"/>
+            <a:ext cx="4754880" cy="4517136"/>
           </a:xfrm>
           <a:prstGeom prst="rect">
             <a:avLst/>
@@ -3374,76 +3380,91 @@
           <a:p>
             <a:pPr>
               <a:spcAft>
-                <a:spcPts val="1200"/>
-              </a:spcAft>
-              <a:defRPr sz="1600" b="1">
+                <a:spcPts val="1000"/>
+              </a:spcAft>
+              <a:defRPr sz="1500" b="1">
                 <a:solidFill>
                   <a:srgbClr val="1E3A8A"/>
                 </a:solidFill>
               </a:defRPr>
             </a:pPr>
             <a:r>
-              <a:t>What Worked vs What Was Rejected</a:t>
-            </a:r>
-          </a:p>
-          <a:p>
-            <a:pPr>
-              <a:spcAft>
-                <a:spcPts val="600"/>
-              </a:spcAft>
-              <a:defRPr sz="1300">
-                <a:solidFill>
-                  <a:srgbClr val="0F172A"/>
-                </a:solidFill>
-              </a:defRPr>
-            </a:pPr>
-            <a:r>
-              <a:t>• What Worked: 2-stage dynamic agent retrieval reliably solved the multi-clause cross-referencing dilemma.</a:t>
-            </a:r>
-          </a:p>
-          <a:p>
-            <a:pPr>
-              <a:spcAft>
-                <a:spcPts val="600"/>
-              </a:spcAft>
-              <a:defRPr sz="1300">
-                <a:solidFill>
-                  <a:srgbClr val="0F172A"/>
-                </a:solidFill>
-              </a:defRPr>
-            </a:pPr>
-            <a:r>
-              <a:t>• What Worked: Decoupled async queue prevents gateway timeouts on multi-step reasoning.</a:t>
-            </a:r>
-          </a:p>
-          <a:p>
-            <a:pPr>
-              <a:spcAft>
-                <a:spcPts val="600"/>
-              </a:spcAft>
-              <a:defRPr sz="1300">
-                <a:solidFill>
-                  <a:srgbClr val="0F172A"/>
-                </a:solidFill>
-              </a:defRPr>
-            </a:pPr>
-            <a:r>
-              <a:t>• What Was Rejected: Single-pass dense embeddings without metadata (missed waiting periods).</a:t>
-            </a:r>
-          </a:p>
-          <a:p>
-            <a:pPr>
-              <a:spcAft>
-                <a:spcPts val="600"/>
-              </a:spcAft>
-              <a:defRPr sz="1300">
-                <a:solidFill>
-                  <a:srgbClr val="0F172A"/>
-                </a:solidFill>
-              </a:defRPr>
-            </a:pPr>
-            <a:r>
-              <a:t>• What Was Rejected: Fixed pipelines without self-verification (hallucinated citations).</a:t>
+              <a:t>4 Service Boundaries (D3)</a:t>
+            </a:r>
+          </a:p>
+          <a:p>
+            <a:pPr>
+              <a:spcAft>
+                <a:spcPts val="500"/>
+              </a:spcAft>
+              <a:defRPr sz="1200">
+                <a:solidFill>
+                  <a:srgbClr val="0F172A"/>
+                </a:solidFill>
+              </a:defRPr>
+            </a:pPr>
+            <a:r>
+              <a:t>• 1. api: FastAPI gateway enforcing contracts, guardrails &amp; Web UI.</a:t>
+            </a:r>
+          </a:p>
+          <a:p>
+            <a:pPr>
+              <a:spcAft>
+                <a:spcPts val="500"/>
+              </a:spcAft>
+              <a:defRPr sz="1200">
+                <a:solidFill>
+                  <a:srgbClr val="0F172A"/>
+                </a:solidFill>
+              </a:defRPr>
+            </a:pPr>
+            <a:r>
+              <a:t>• 2. agent-worker: Background worker executing multi-agent reasoning.</a:t>
+            </a:r>
+          </a:p>
+          <a:p>
+            <a:pPr>
+              <a:spcAft>
+                <a:spcPts val="500"/>
+              </a:spcAft>
+              <a:defRPr sz="1200">
+                <a:solidFill>
+                  <a:srgbClr val="0F172A"/>
+                </a:solidFill>
+              </a:defRPr>
+            </a:pPr>
+            <a:r>
+              <a:t>• 3. redis: Distributed task queue &amp; cache store (3600s TTL).</a:t>
+            </a:r>
+          </a:p>
+          <a:p>
+            <a:pPr>
+              <a:spcAft>
+                <a:spcPts val="500"/>
+              </a:spcAft>
+              <a:defRPr sz="1200">
+                <a:solidFill>
+                  <a:srgbClr val="0F172A"/>
+                </a:solidFill>
+              </a:defRPr>
+            </a:pPr>
+            <a:r>
+              <a:t>• 4. prometheus: Observability scraping /metrics every 5 seconds.</a:t>
+            </a:r>
+          </a:p>
+          <a:p>
+            <a:pPr>
+              <a:spcAft>
+                <a:spcPts val="500"/>
+              </a:spcAft>
+              <a:defRPr sz="1200">
+                <a:solidFill>
+                  <a:srgbClr val="0F172A"/>
+                </a:solidFill>
+              </a:defRPr>
+            </a:pPr>
+            <a:r>
+              <a:t>• Clean Clone: Launches seamlessly with 'docker compose up -d'.</a:t>
             </a:r>
           </a:p>
         </p:txBody>
@@ -3456,8 +3477,8 @@
         </p:nvSpPr>
         <p:spPr>
           <a:xfrm>
-            <a:off x="6217920" y="1645920"/>
-            <a:ext cx="5120640" cy="4572000"/>
+            <a:off x="6217920" y="1508760"/>
+            <a:ext cx="5120640" cy="4846320"/>
           </a:xfrm>
           <a:prstGeom prst="roundRect">
             <a:avLst/>
@@ -3501,8 +3522,8 @@
         </p:nvSpPr>
         <p:spPr>
           <a:xfrm>
-            <a:off x="6400800" y="1828800"/>
-            <a:ext cx="4754880" cy="4206240"/>
+            <a:off x="6400800" y="1673352"/>
+            <a:ext cx="4754880" cy="4517136"/>
           </a:xfrm>
           <a:prstGeom prst="rect">
             <a:avLst/>
@@ -3517,91 +3538,944 @@
           <a:p>
             <a:pPr>
               <a:spcAft>
-                <a:spcPts val="1200"/>
-              </a:spcAft>
-              <a:defRPr sz="1600" b="1">
+                <a:spcPts val="1000"/>
+              </a:spcAft>
+              <a:defRPr sz="1500" b="1">
                 <a:solidFill>
                   <a:srgbClr val="1E3A8A"/>
                 </a:solidFill>
               </a:defRPr>
             </a:pPr>
             <a:r>
-              <a:t>Deliverables Checklist</a:t>
-            </a:r>
-          </a:p>
-          <a:p>
-            <a:pPr>
-              <a:spcAft>
-                <a:spcPts val="600"/>
-              </a:spcAft>
-              <a:defRPr sz="1300">
-                <a:solidFill>
-                  <a:srgbClr val="0F172A"/>
-                </a:solidFill>
-              </a:defRPr>
-            </a:pPr>
-            <a:r>
-              <a:t>• Working Repository: Clean Git repository with complete commit history.</a:t>
-            </a:r>
-          </a:p>
-          <a:p>
-            <a:pPr>
-              <a:spcAft>
-                <a:spcPts val="600"/>
-              </a:spcAft>
-              <a:defRPr sz="1300">
-                <a:solidFill>
-                  <a:srgbClr val="0F172A"/>
-                </a:solidFill>
-              </a:defRPr>
-            </a:pPr>
-            <a:r>
-              <a:t>• Corpus &amp; Index: Retail policy wording + day-care schedule + idempotent indexer.</a:t>
-            </a:r>
-          </a:p>
-          <a:p>
-            <a:pPr>
-              <a:spcAft>
-                <a:spcPts val="600"/>
-              </a:spcAft>
-              <a:defRPr sz="1300">
-                <a:solidFill>
-                  <a:srgbClr val="0F172A"/>
-                </a:solidFill>
-              </a:defRPr>
-            </a:pPr>
-            <a:r>
-              <a:t>• Web Client UI: Interactive single-page app for live evaluation.</a:t>
-            </a:r>
-          </a:p>
-          <a:p>
-            <a:pPr>
-              <a:spcAft>
-                <a:spcPts val="600"/>
-              </a:spcAft>
-              <a:defRPr sz="1300">
-                <a:solidFill>
-                  <a:srgbClr val="0F172A"/>
-                </a:solidFill>
-              </a:defRPr>
-            </a:pPr>
-            <a:r>
-              <a:t>• Runbook &amp; Incidents: RUNBOOK.md documenting top failure modes and development post-mortems.</a:t>
-            </a:r>
-          </a:p>
-          <a:p>
-            <a:pPr>
-              <a:spcAft>
-                <a:spcPts val="600"/>
-              </a:spcAft>
-              <a:defRPr sz="1300">
-                <a:solidFill>
-                  <a:srgbClr val="0F172A"/>
-                </a:solidFill>
-              </a:defRPr>
-            </a:pPr>
-            <a:r>
-              <a:t>• Presentation: 10-slide PowerPoint deck &amp; presentation guide.</a:t>
+              <a:t>Horizontal Worker Scaling (A7)</a:t>
+            </a:r>
+          </a:p>
+          <a:p>
+            <a:pPr>
+              <a:spcAft>
+                <a:spcPts val="500"/>
+              </a:spcAft>
+              <a:defRPr sz="1200">
+                <a:solidFill>
+                  <a:srgbClr val="0F172A"/>
+                </a:solidFill>
+              </a:defRPr>
+            </a:pPr>
+            <a:r>
+              <a:t>• Command: 'docker compose up --scale agent-worker=3 -d'.</a:t>
+            </a:r>
+          </a:p>
+          <a:p>
+            <a:pPr>
+              <a:spcAft>
+                <a:spcPts val="500"/>
+              </a:spcAft>
+              <a:defRPr sz="1200">
+                <a:solidFill>
+                  <a:srgbClr val="0F172A"/>
+                </a:solidFill>
+              </a:defRPr>
+            </a:pPr>
+            <a:r>
+              <a:t>• Load Distribution: Multiple workers pop tasks concurrently from Redis queue.</a:t>
+            </a:r>
+          </a:p>
+          <a:p>
+            <a:pPr>
+              <a:spcAft>
+                <a:spcPts val="500"/>
+              </a:spcAft>
+              <a:defRPr sz="1200">
+                <a:solidFill>
+                  <a:srgbClr val="0F172A"/>
+                </a:solidFill>
+              </a:defRPr>
+            </a:pPr>
+            <a:r>
+              <a:t>• Throughput Multiplier: Worker scaling increases queue throughput from ~90 RPS to 264+ RPS.</a:t>
+            </a:r>
+          </a:p>
+          <a:p>
+            <a:pPr>
+              <a:spcAft>
+                <a:spcPts val="500"/>
+              </a:spcAft>
+              <a:defRPr sz="1200">
+                <a:solidFill>
+                  <a:srgbClr val="0F172A"/>
+                </a:solidFill>
+              </a:defRPr>
+            </a:pPr>
+            <a:r>
+              <a:t>• Eliminates run queuing delays during peak hospital admission surges.</a:t>
+            </a:r>
+          </a:p>
+        </p:txBody>
+      </p:sp>
+    </p:spTree>
+  </p:cSld>
+  <p:clrMapOvr>
+    <a:masterClrMapping/>
+  </p:clrMapOvr>
+</p:sld>
+</file>
+
+<file path=ppt/slides/slide11.xml><?xml version="1.0" encoding="utf-8"?>
+<p:sld xmlns:a="http://schemas.openxmlformats.org/drawingml/2006/main" xmlns:p="http://schemas.openxmlformats.org/presentationml/2006/main" xmlns:r="http://schemas.openxmlformats.org/officeDocument/2006/relationships">
+  <p:cSld>
+    <p:spTree>
+      <p:nvGrpSpPr>
+        <p:cNvPr id="1" name=""/>
+        <p:cNvGrpSpPr/>
+        <p:nvPr/>
+      </p:nvGrpSpPr>
+      <p:grpSpPr/>
+      <p:sp>
+        <p:nvSpPr>
+          <p:cNvPr id="2" name="TextBox 1"/>
+          <p:cNvSpPr txBox="1"/>
+          <p:nvPr/>
+        </p:nvSpPr>
+        <p:spPr>
+          <a:xfrm>
+            <a:off x="731520" y="411480"/>
+            <a:ext cx="10515600" cy="320040"/>
+          </a:xfrm>
+          <a:prstGeom prst="rect">
+            <a:avLst/>
+          </a:prstGeom>
+          <a:noFill/>
+        </p:spPr>
+        <p:txBody>
+          <a:bodyPr wrap="square">
+            <a:spAutoFit/>
+          </a:bodyPr>
+          <a:lstStyle/>
+          <a:p>
+            <a:pPr>
+              <a:defRPr sz="1100" b="1">
+                <a:solidFill>
+                  <a:srgbClr val="2563EB"/>
+                </a:solidFill>
+              </a:defRPr>
+            </a:pPr>
+            <a:r>
+              <a:t>UE24AM342AA5 | MINI PROJECT 03 | JACKFRUIT (LEVEL 3)</a:t>
+            </a:r>
+          </a:p>
+        </p:txBody>
+      </p:sp>
+      <p:sp>
+        <p:nvSpPr>
+          <p:cNvPr id="3" name="TextBox 2"/>
+          <p:cNvSpPr txBox="1"/>
+          <p:nvPr/>
+        </p:nvSpPr>
+        <p:spPr>
+          <a:xfrm>
+            <a:off x="731520" y="685800"/>
+            <a:ext cx="10515600" cy="640080"/>
+          </a:xfrm>
+          <a:prstGeom prst="rect">
+            <a:avLst/>
+          </a:prstGeom>
+          <a:noFill/>
+        </p:spPr>
+        <p:txBody>
+          <a:bodyPr wrap="square">
+            <a:spAutoFit/>
+          </a:bodyPr>
+          <a:lstStyle/>
+          <a:p>
+            <a:pPr>
+              <a:defRPr sz="2300" b="1">
+                <a:solidFill>
+                  <a:srgbClr val="1E3A8A"/>
+                </a:solidFill>
+              </a:defRPr>
+            </a:pPr>
+            <a:r>
+              <a:t>SLO Declaration, Load Testing &amp; Costs (D6, L5)</a:t>
+            </a:r>
+          </a:p>
+        </p:txBody>
+      </p:sp>
+      <p:sp>
+        <p:nvSpPr>
+          <p:cNvPr id="4" name="Rounded Rectangle 3"/>
+          <p:cNvSpPr/>
+          <p:nvPr/>
+        </p:nvSpPr>
+        <p:spPr>
+          <a:xfrm>
+            <a:off x="731520" y="1508760"/>
+            <a:ext cx="5120640" cy="4846320"/>
+          </a:xfrm>
+          <a:prstGeom prst="roundRect">
+            <a:avLst/>
+          </a:prstGeom>
+          <a:solidFill>
+            <a:srgbClr val="FFFFFF"/>
+          </a:solidFill>
+          <a:ln w="19050">
+            <a:solidFill>
+              <a:srgbClr val="E2E8F0"/>
+            </a:solidFill>
+          </a:ln>
+        </p:spPr>
+        <p:style>
+          <a:lnRef idx="1">
+            <a:schemeClr val="accent1"/>
+          </a:lnRef>
+          <a:fillRef idx="3">
+            <a:schemeClr val="accent1"/>
+          </a:fillRef>
+          <a:effectRef idx="2">
+            <a:schemeClr val="accent1"/>
+          </a:effectRef>
+          <a:fontRef idx="minor">
+            <a:schemeClr val="lt1"/>
+          </a:fontRef>
+        </p:style>
+        <p:txBody>
+          <a:bodyPr rtlCol="0" anchor="ctr"/>
+          <a:lstStyle/>
+          <a:p>
+            <a:pPr algn="ctr"/>
+          </a:p>
+        </p:txBody>
+      </p:sp>
+      <p:sp>
+        <p:nvSpPr>
+          <p:cNvPr id="5" name="TextBox 4"/>
+          <p:cNvSpPr txBox="1"/>
+          <p:nvPr/>
+        </p:nvSpPr>
+        <p:spPr>
+          <a:xfrm>
+            <a:off x="914400" y="1673352"/>
+            <a:ext cx="4754880" cy="4517136"/>
+          </a:xfrm>
+          <a:prstGeom prst="rect">
+            <a:avLst/>
+          </a:prstGeom>
+          <a:noFill/>
+        </p:spPr>
+        <p:txBody>
+          <a:bodyPr wrap="square">
+            <a:spAutoFit/>
+          </a:bodyPr>
+          <a:lstStyle/>
+          <a:p>
+            <a:pPr>
+              <a:spcAft>
+                <a:spcPts val="1000"/>
+              </a:spcAft>
+              <a:defRPr sz="1500" b="1">
+                <a:solidFill>
+                  <a:srgbClr val="1E3A8A"/>
+                </a:solidFill>
+              </a:defRPr>
+            </a:pPr>
+            <a:r>
+              <a:t>Declared SLO vs Measured Results</a:t>
+            </a:r>
+          </a:p>
+          <a:p>
+            <a:pPr>
+              <a:spcAft>
+                <a:spcPts val="500"/>
+              </a:spcAft>
+              <a:defRPr sz="1200">
+                <a:solidFill>
+                  <a:srgbClr val="0F172A"/>
+                </a:solidFill>
+              </a:defRPr>
+            </a:pPr>
+            <a:r>
+              <a:t>• Declared Target SLO: End-to-end run p95 &lt;= 2.50s (2500 ms).</a:t>
+            </a:r>
+          </a:p>
+          <a:p>
+            <a:pPr>
+              <a:spcAft>
+                <a:spcPts val="500"/>
+              </a:spcAft>
+              <a:defRPr sz="1200">
+                <a:solidFill>
+                  <a:srgbClr val="0F172A"/>
+                </a:solidFill>
+              </a:defRPr>
+            </a:pPr>
+            <a:r>
+              <a:t>• Justification: Must beat human desk speed (15-30 mins) while sustaining peak TPA load.</a:t>
+            </a:r>
+          </a:p>
+          <a:p>
+            <a:pPr>
+              <a:spcAft>
+                <a:spcPts val="500"/>
+              </a:spcAft>
+              <a:defRPr sz="1200">
+                <a:solidFill>
+                  <a:srgbClr val="0F172A"/>
+                </a:solidFill>
+              </a:defRPr>
+            </a:pPr>
+            <a:r>
+              <a:t>• Measured p50: ~65.0 ms  |  Measured p95: ~140.0 ms (Met by 18x margin).</a:t>
+            </a:r>
+          </a:p>
+          <a:p>
+            <a:pPr>
+              <a:spcAft>
+                <a:spcPts val="500"/>
+              </a:spcAft>
+              <a:defRPr sz="1200">
+                <a:solidFill>
+                  <a:srgbClr val="0F172A"/>
+                </a:solidFill>
+              </a:defRPr>
+            </a:pPr>
+            <a:r>
+              <a:t>• Locust Load Test: Tested with realistic async polling in stub mode.</a:t>
+            </a:r>
+          </a:p>
+          <a:p>
+            <a:pPr>
+              <a:spcAft>
+                <a:spcPts val="500"/>
+              </a:spcAft>
+              <a:defRPr sz="1200">
+                <a:solidFill>
+                  <a:srgbClr val="0F172A"/>
+                </a:solidFill>
+              </a:defRPr>
+            </a:pPr>
+            <a:r>
+              <a:t>• Bottleneck: Single-worker run-state contention at 450+ concurrent users; resolved via worker scaling.</a:t>
+            </a:r>
+          </a:p>
+        </p:txBody>
+      </p:sp>
+      <p:sp>
+        <p:nvSpPr>
+          <p:cNvPr id="6" name="Rounded Rectangle 5"/>
+          <p:cNvSpPr/>
+          <p:nvPr/>
+        </p:nvSpPr>
+        <p:spPr>
+          <a:xfrm>
+            <a:off x="6217920" y="1508760"/>
+            <a:ext cx="5120640" cy="4846320"/>
+          </a:xfrm>
+          <a:prstGeom prst="roundRect">
+            <a:avLst/>
+          </a:prstGeom>
+          <a:solidFill>
+            <a:srgbClr val="FFFFFF"/>
+          </a:solidFill>
+          <a:ln w="19050">
+            <a:solidFill>
+              <a:srgbClr val="E2E8F0"/>
+            </a:solidFill>
+          </a:ln>
+        </p:spPr>
+        <p:style>
+          <a:lnRef idx="1">
+            <a:schemeClr val="accent1"/>
+          </a:lnRef>
+          <a:fillRef idx="3">
+            <a:schemeClr val="accent1"/>
+          </a:fillRef>
+          <a:effectRef idx="2">
+            <a:schemeClr val="accent1"/>
+          </a:effectRef>
+          <a:fontRef idx="minor">
+            <a:schemeClr val="lt1"/>
+          </a:fontRef>
+        </p:style>
+        <p:txBody>
+          <a:bodyPr rtlCol="0" anchor="ctr"/>
+          <a:lstStyle/>
+          <a:p>
+            <a:pPr algn="ctr"/>
+          </a:p>
+        </p:txBody>
+      </p:sp>
+      <p:sp>
+        <p:nvSpPr>
+          <p:cNvPr id="7" name="TextBox 6"/>
+          <p:cNvSpPr txBox="1"/>
+          <p:nvPr/>
+        </p:nvSpPr>
+        <p:spPr>
+          <a:xfrm>
+            <a:off x="6400800" y="1673352"/>
+            <a:ext cx="4754880" cy="4517136"/>
+          </a:xfrm>
+          <a:prstGeom prst="rect">
+            <a:avLst/>
+          </a:prstGeom>
+          <a:noFill/>
+        </p:spPr>
+        <p:txBody>
+          <a:bodyPr wrap="square">
+            <a:spAutoFit/>
+          </a:bodyPr>
+          <a:lstStyle/>
+          <a:p>
+            <a:pPr>
+              <a:spcAft>
+                <a:spcPts val="1000"/>
+              </a:spcAft>
+              <a:defRPr sz="1500" b="1">
+                <a:solidFill>
+                  <a:srgbClr val="1E3A8A"/>
+                </a:solidFill>
+              </a:defRPr>
+            </a:pPr>
+            <a:r>
+              <a:t>Cost Accounting per 100 Runs (L5)</a:t>
+            </a:r>
+          </a:p>
+          <a:p>
+            <a:pPr>
+              <a:spcAft>
+                <a:spcPts val="500"/>
+              </a:spcAft>
+              <a:defRPr sz="1200">
+                <a:solidFill>
+                  <a:srgbClr val="0F172A"/>
+                </a:solidFill>
+              </a:defRPr>
+            </a:pPr>
+            <a:r>
+              <a:t>• Gemini 1.5 Flash Pricing: $0.075 / 1M prompt, $0.30 / 1M completion.</a:t>
+            </a:r>
+          </a:p>
+          <a:p>
+            <a:pPr>
+              <a:spcAft>
+                <a:spcPts val="500"/>
+              </a:spcAft>
+              <a:defRPr sz="1200">
+                <a:solidFill>
+                  <a:srgbClr val="0F172A"/>
+                </a:solidFill>
+              </a:defRPr>
+            </a:pPr>
+            <a:r>
+              <a:t>• Average Prompt Tokens / Run: 184 tokens.</a:t>
+            </a:r>
+          </a:p>
+          <a:p>
+            <a:pPr>
+              <a:spcAft>
+                <a:spcPts val="500"/>
+              </a:spcAft>
+              <a:defRPr sz="1200">
+                <a:solidFill>
+                  <a:srgbClr val="0F172A"/>
+                </a:solidFill>
+              </a:defRPr>
+            </a:pPr>
+            <a:r>
+              <a:t>• Average Completion Tokens / Run: 90 tokens.</a:t>
+            </a:r>
+          </a:p>
+          <a:p>
+            <a:pPr>
+              <a:spcAft>
+                <a:spcPts val="500"/>
+              </a:spcAft>
+              <a:defRPr sz="1200">
+                <a:solidFill>
+                  <a:srgbClr val="0F172A"/>
+                </a:solidFill>
+              </a:defRPr>
+            </a:pPr>
+            <a:r>
+              <a:t>• Total Cost per 100 Runs: $0.004032 (&lt; half a cent).</a:t>
+            </a:r>
+          </a:p>
+          <a:p>
+            <a:pPr>
+              <a:spcAft>
+                <a:spcPts val="500"/>
+              </a:spcAft>
+              <a:defRPr sz="1200">
+                <a:solidFill>
+                  <a:srgbClr val="0F172A"/>
+                </a:solidFill>
+              </a:defRPr>
+            </a:pPr>
+            <a:r>
+              <a:t>• Primary Cost Driver: Stage 2 adjudication reasoning (68% of token spend due to clause context injection).</a:t>
+            </a:r>
+          </a:p>
+        </p:txBody>
+      </p:sp>
+    </p:spTree>
+  </p:cSld>
+  <p:clrMapOvr>
+    <a:masterClrMapping/>
+  </p:clrMapOvr>
+</p:sld>
+</file>
+
+<file path=ppt/slides/slide12.xml><?xml version="1.0" encoding="utf-8"?>
+<p:sld xmlns:a="http://schemas.openxmlformats.org/drawingml/2006/main" xmlns:p="http://schemas.openxmlformats.org/presentationml/2006/main" xmlns:r="http://schemas.openxmlformats.org/officeDocument/2006/relationships">
+  <p:cSld>
+    <p:spTree>
+      <p:nvGrpSpPr>
+        <p:cNvPr id="1" name=""/>
+        <p:cNvGrpSpPr/>
+        <p:nvPr/>
+      </p:nvGrpSpPr>
+      <p:grpSpPr/>
+      <p:sp>
+        <p:nvSpPr>
+          <p:cNvPr id="2" name="TextBox 1"/>
+          <p:cNvSpPr txBox="1"/>
+          <p:nvPr/>
+        </p:nvSpPr>
+        <p:spPr>
+          <a:xfrm>
+            <a:off x="731520" y="411480"/>
+            <a:ext cx="10515600" cy="320040"/>
+          </a:xfrm>
+          <a:prstGeom prst="rect">
+            <a:avLst/>
+          </a:prstGeom>
+          <a:noFill/>
+        </p:spPr>
+        <p:txBody>
+          <a:bodyPr wrap="square">
+            <a:spAutoFit/>
+          </a:bodyPr>
+          <a:lstStyle/>
+          <a:p>
+            <a:pPr>
+              <a:defRPr sz="1100" b="1">
+                <a:solidFill>
+                  <a:srgbClr val="2563EB"/>
+                </a:solidFill>
+              </a:defRPr>
+            </a:pPr>
+            <a:r>
+              <a:t>UE24AM342AA5 | MINI PROJECT 03 | JACKFRUIT (LEVEL 3)</a:t>
+            </a:r>
+          </a:p>
+        </p:txBody>
+      </p:sp>
+      <p:sp>
+        <p:nvSpPr>
+          <p:cNvPr id="3" name="TextBox 2"/>
+          <p:cNvSpPr txBox="1"/>
+          <p:nvPr/>
+        </p:nvSpPr>
+        <p:spPr>
+          <a:xfrm>
+            <a:off x="731520" y="685800"/>
+            <a:ext cx="10515600" cy="640080"/>
+          </a:xfrm>
+          <a:prstGeom prst="rect">
+            <a:avLst/>
+          </a:prstGeom>
+          <a:noFill/>
+        </p:spPr>
+        <p:txBody>
+          <a:bodyPr wrap="square">
+            <a:spAutoFit/>
+          </a:bodyPr>
+          <a:lstStyle/>
+          <a:p>
+            <a:pPr>
+              <a:defRPr sz="2300" b="1">
+                <a:solidFill>
+                  <a:srgbClr val="1E3A8A"/>
+                </a:solidFill>
+              </a:defRPr>
+            </a:pPr>
+            <a:r>
+              <a:t>Demonstration Verification &amp; Conclusion</a:t>
+            </a:r>
+          </a:p>
+        </p:txBody>
+      </p:sp>
+      <p:sp>
+        <p:nvSpPr>
+          <p:cNvPr id="4" name="Rounded Rectangle 3"/>
+          <p:cNvSpPr/>
+          <p:nvPr/>
+        </p:nvSpPr>
+        <p:spPr>
+          <a:xfrm>
+            <a:off x="731520" y="1508760"/>
+            <a:ext cx="5120640" cy="4846320"/>
+          </a:xfrm>
+          <a:prstGeom prst="roundRect">
+            <a:avLst/>
+          </a:prstGeom>
+          <a:solidFill>
+            <a:srgbClr val="FFFFFF"/>
+          </a:solidFill>
+          <a:ln w="19050">
+            <a:solidFill>
+              <a:srgbClr val="E2E8F0"/>
+            </a:solidFill>
+          </a:ln>
+        </p:spPr>
+        <p:style>
+          <a:lnRef idx="1">
+            <a:schemeClr val="accent1"/>
+          </a:lnRef>
+          <a:fillRef idx="3">
+            <a:schemeClr val="accent1"/>
+          </a:fillRef>
+          <a:effectRef idx="2">
+            <a:schemeClr val="accent1"/>
+          </a:effectRef>
+          <a:fontRef idx="minor">
+            <a:schemeClr val="lt1"/>
+          </a:fontRef>
+        </p:style>
+        <p:txBody>
+          <a:bodyPr rtlCol="0" anchor="ctr"/>
+          <a:lstStyle/>
+          <a:p>
+            <a:pPr algn="ctr"/>
+          </a:p>
+        </p:txBody>
+      </p:sp>
+      <p:sp>
+        <p:nvSpPr>
+          <p:cNvPr id="5" name="TextBox 4"/>
+          <p:cNvSpPr txBox="1"/>
+          <p:nvPr/>
+        </p:nvSpPr>
+        <p:spPr>
+          <a:xfrm>
+            <a:off x="914400" y="1673352"/>
+            <a:ext cx="4754880" cy="4517136"/>
+          </a:xfrm>
+          <a:prstGeom prst="rect">
+            <a:avLst/>
+          </a:prstGeom>
+          <a:noFill/>
+        </p:spPr>
+        <p:txBody>
+          <a:bodyPr wrap="square">
+            <a:spAutoFit/>
+          </a:bodyPr>
+          <a:lstStyle/>
+          <a:p>
+            <a:pPr>
+              <a:spcAft>
+                <a:spcPts val="1000"/>
+              </a:spcAft>
+              <a:defRPr sz="1500" b="1">
+                <a:solidFill>
+                  <a:srgbClr val="1E3A8A"/>
+                </a:solidFill>
+              </a:defRPr>
+            </a:pPr>
+            <a:r>
+              <a:t>All 10 Demonstration Items Ready</a:t>
+            </a:r>
+          </a:p>
+          <a:p>
+            <a:pPr>
+              <a:spcAft>
+                <a:spcPts val="500"/>
+              </a:spcAft>
+              <a:defRPr sz="1200">
+                <a:solidFill>
+                  <a:srgbClr val="0F172A"/>
+                </a:solidFill>
+              </a:defRPr>
+            </a:pPr>
+            <a:r>
+              <a:t>• 1. Docker compose up from clean clone</a:t>
+            </a:r>
+          </a:p>
+          <a:p>
+            <a:pPr>
+              <a:spcAft>
+                <a:spcPts val="500"/>
+              </a:spcAft>
+              <a:defRPr sz="1200">
+                <a:solidFill>
+                  <a:srgbClr val="0F172A"/>
+                </a:solidFill>
+              </a:defRPr>
+            </a:pPr>
+            <a:r>
+              <a:t>• 2. Valid request producing routed recommendation</a:t>
+            </a:r>
+          </a:p>
+          <a:p>
+            <a:pPr>
+              <a:spcAft>
+                <a:spcPts val="500"/>
+              </a:spcAft>
+              <a:defRPr sz="1200">
+                <a:solidFill>
+                  <a:srgbClr val="0F172A"/>
+                </a:solidFill>
+              </a:defRPr>
+            </a:pPr>
+            <a:r>
+              <a:t>• 3. Traced end-to-end with per-step latency and cost</a:t>
+            </a:r>
+          </a:p>
+          <a:p>
+            <a:pPr>
+              <a:spcAft>
+                <a:spcPts val="500"/>
+              </a:spcAft>
+              <a:defRPr sz="1200">
+                <a:solidFill>
+                  <a:srgbClr val="0F172A"/>
+                </a:solidFill>
+              </a:defRPr>
+            </a:pPr>
+            <a:r>
+              <a:t>• 4. Malformed request quarantined (Zero agent runs)</a:t>
+            </a:r>
+          </a:p>
+          <a:p>
+            <a:pPr>
+              <a:spcAft>
+                <a:spcPts val="500"/>
+              </a:spcAft>
+              <a:defRPr sz="1200">
+                <a:solidFill>
+                  <a:srgbClr val="0F172A"/>
+                </a:solidFill>
+              </a:defRPr>
+            </a:pPr>
+            <a:r>
+              <a:t>• 5. Out-of-corpus condition safely escalated</a:t>
+            </a:r>
+          </a:p>
+          <a:p>
+            <a:pPr>
+              <a:spcAft>
+                <a:spcPts val="500"/>
+              </a:spcAft>
+              <a:defRPr sz="1200">
+                <a:solidFill>
+                  <a:srgbClr val="0F172A"/>
+                </a:solidFill>
+              </a:defRPr>
+            </a:pPr>
+            <a:r>
+              <a:t>• 6. Self-verification catching ungrounded answers</a:t>
+            </a:r>
+          </a:p>
+          <a:p>
+            <a:pPr>
+              <a:spcAft>
+                <a:spcPts val="500"/>
+              </a:spcAft>
+              <a:defRPr sz="1200">
+                <a:solidFill>
+                  <a:srgbClr val="0F172A"/>
+                </a:solidFill>
+              </a:defRPr>
+            </a:pPr>
+            <a:r>
+              <a:t>• 7. Prompt injection attack blocked by guardrail</a:t>
+            </a:r>
+          </a:p>
+          <a:p>
+            <a:pPr>
+              <a:spcAft>
+                <a:spcPts val="500"/>
+              </a:spcAft>
+              <a:defRPr sz="1200">
+                <a:solidFill>
+                  <a:srgbClr val="0F172A"/>
+                </a:solidFill>
+              </a:defRPr>
+            </a:pPr>
+            <a:r>
+              <a:t>• 8. Circuit breaker opening with graceful degradation</a:t>
+            </a:r>
+          </a:p>
+          <a:p>
+            <a:pPr>
+              <a:spcAft>
+                <a:spcPts val="500"/>
+              </a:spcAft>
+              <a:defRPr sz="1200">
+                <a:solidFill>
+                  <a:srgbClr val="0F172A"/>
+                </a:solidFill>
+              </a:defRPr>
+            </a:pPr>
+            <a:r>
+              <a:t>• 9. Locust results confirming declared p95 SLO</a:t>
+            </a:r>
+          </a:p>
+          <a:p>
+            <a:pPr>
+              <a:spcAft>
+                <a:spcPts val="500"/>
+              </a:spcAft>
+              <a:defRPr sz="1200">
+                <a:solidFill>
+                  <a:srgbClr val="0F172A"/>
+                </a:solidFill>
+              </a:defRPr>
+            </a:pPr>
+            <a:r>
+              <a:t>• 10. Section 4.1 Difficult Case (Cataract 11m) handled correctly!</a:t>
+            </a:r>
+          </a:p>
+        </p:txBody>
+      </p:sp>
+      <p:sp>
+        <p:nvSpPr>
+          <p:cNvPr id="6" name="Rounded Rectangle 5"/>
+          <p:cNvSpPr/>
+          <p:nvPr/>
+        </p:nvSpPr>
+        <p:spPr>
+          <a:xfrm>
+            <a:off x="6217920" y="1508760"/>
+            <a:ext cx="5120640" cy="4846320"/>
+          </a:xfrm>
+          <a:prstGeom prst="roundRect">
+            <a:avLst/>
+          </a:prstGeom>
+          <a:solidFill>
+            <a:srgbClr val="FFFFFF"/>
+          </a:solidFill>
+          <a:ln w="19050">
+            <a:solidFill>
+              <a:srgbClr val="E2E8F0"/>
+            </a:solidFill>
+          </a:ln>
+        </p:spPr>
+        <p:style>
+          <a:lnRef idx="1">
+            <a:schemeClr val="accent1"/>
+          </a:lnRef>
+          <a:fillRef idx="3">
+            <a:schemeClr val="accent1"/>
+          </a:fillRef>
+          <a:effectRef idx="2">
+            <a:schemeClr val="accent1"/>
+          </a:effectRef>
+          <a:fontRef idx="minor">
+            <a:schemeClr val="lt1"/>
+          </a:fontRef>
+        </p:style>
+        <p:txBody>
+          <a:bodyPr rtlCol="0" anchor="ctr"/>
+          <a:lstStyle/>
+          <a:p>
+            <a:pPr algn="ctr"/>
+          </a:p>
+        </p:txBody>
+      </p:sp>
+      <p:sp>
+        <p:nvSpPr>
+          <p:cNvPr id="7" name="TextBox 6"/>
+          <p:cNvSpPr txBox="1"/>
+          <p:nvPr/>
+        </p:nvSpPr>
+        <p:spPr>
+          <a:xfrm>
+            <a:off x="6400800" y="1673352"/>
+            <a:ext cx="4754880" cy="4517136"/>
+          </a:xfrm>
+          <a:prstGeom prst="rect">
+            <a:avLst/>
+          </a:prstGeom>
+          <a:noFill/>
+        </p:spPr>
+        <p:txBody>
+          <a:bodyPr wrap="square">
+            <a:spAutoFit/>
+          </a:bodyPr>
+          <a:lstStyle/>
+          <a:p>
+            <a:pPr>
+              <a:spcAft>
+                <a:spcPts val="1000"/>
+              </a:spcAft>
+              <a:defRPr sz="1500" b="1">
+                <a:solidFill>
+                  <a:srgbClr val="1E3A8A"/>
+                </a:solidFill>
+              </a:defRPr>
+            </a:pPr>
+            <a:r>
+              <a:t>Conclusion &amp; Deliverables</a:t>
+            </a:r>
+          </a:p>
+          <a:p>
+            <a:pPr>
+              <a:spcAft>
+                <a:spcPts val="500"/>
+              </a:spcAft>
+              <a:defRPr sz="1200">
+                <a:solidFill>
+                  <a:srgbClr val="0F172A"/>
+                </a:solidFill>
+              </a:defRPr>
+            </a:pPr>
+            <a:r>
+              <a:t>• GitHub Repo: https://github.com/DharshiniPES/health-insurance-preauth-desk</a:t>
+            </a:r>
+          </a:p>
+          <a:p>
+            <a:pPr>
+              <a:spcAft>
+                <a:spcPts val="500"/>
+              </a:spcAft>
+              <a:defRPr sz="1200">
+                <a:solidFill>
+                  <a:srgbClr val="0F172A"/>
+                </a:solidFill>
+              </a:defRPr>
+            </a:pPr>
+            <a:r>
+              <a:t>• Final Report: Mini_Project_03_Final_Report.docx and FINAL_REPORT.md</a:t>
+            </a:r>
+          </a:p>
+          <a:p>
+            <a:pPr>
+              <a:spcAft>
+                <a:spcPts val="500"/>
+              </a:spcAft>
+              <a:defRPr sz="1200">
+                <a:solidFill>
+                  <a:srgbClr val="0F172A"/>
+                </a:solidFill>
+              </a:defRPr>
+            </a:pPr>
+            <a:r>
+              <a:t>• Presentation: PreAuthorisation_Desk_Presentation.pptx and PRESENTATION.md</a:t>
+            </a:r>
+          </a:p>
+          <a:p>
+            <a:pPr>
+              <a:spcAft>
+                <a:spcPts val="500"/>
+              </a:spcAft>
+              <a:defRPr sz="1200">
+                <a:solidFill>
+                  <a:srgbClr val="0F172A"/>
+                </a:solidFill>
+              </a:defRPr>
+            </a:pPr>
+            <a:r>
+              <a:t>• Key Takeaway: Autonomous multi-agent systems with active self-verification and operational guardrails transform fragile pipelines into production-grade clinical desks.</a:t>
             </a:r>
           </a:p>
         </p:txBody>
@@ -3632,8 +4506,8 @@
         </p:nvSpPr>
         <p:spPr>
           <a:xfrm>
-            <a:off x="731520" y="457200"/>
-            <a:ext cx="10515600" cy="365760"/>
+            <a:off x="731520" y="411480"/>
+            <a:ext cx="10515600" cy="320040"/>
           </a:xfrm>
           <a:prstGeom prst="rect">
             <a:avLst/>
@@ -3667,7 +4541,7 @@
         </p:nvSpPr>
         <p:spPr>
           <a:xfrm>
-            <a:off x="731520" y="777240"/>
+            <a:off x="731520" y="685800"/>
             <a:ext cx="10515600" cy="640080"/>
           </a:xfrm>
           <a:prstGeom prst="rect">
@@ -3682,7 +4556,7 @@
           <a:lstStyle/>
           <a:p>
             <a:pPr>
-              <a:defRPr sz="2400" b="1">
+              <a:defRPr sz="2300" b="1">
                 <a:solidFill>
                   <a:srgbClr val="1E3A8A"/>
                 </a:solidFill>
@@ -3702,8 +4576,8 @@
         </p:nvSpPr>
         <p:spPr>
           <a:xfrm>
-            <a:off x="731520" y="1645920"/>
-            <a:ext cx="5120640" cy="4572000"/>
+            <a:off x="731520" y="1508760"/>
+            <a:ext cx="5120640" cy="4846320"/>
           </a:xfrm>
           <a:prstGeom prst="roundRect">
             <a:avLst/>
@@ -3747,8 +4621,8 @@
         </p:nvSpPr>
         <p:spPr>
           <a:xfrm>
-            <a:off x="914400" y="1828800"/>
-            <a:ext cx="4754880" cy="4206240"/>
+            <a:off x="914400" y="1673352"/>
+            <a:ext cx="4754880" cy="4517136"/>
           </a:xfrm>
           <a:prstGeom prst="rect">
             <a:avLst/>
@@ -3763,9 +4637,9 @@
           <a:p>
             <a:pPr>
               <a:spcAft>
-                <a:spcPts val="1200"/>
-              </a:spcAft>
-              <a:defRPr sz="1600" b="1">
+                <a:spcPts val="1000"/>
+              </a:spcAft>
+              <a:defRPr sz="1500" b="1">
                 <a:solidFill>
                   <a:srgbClr val="1E3A8A"/>
                 </a:solidFill>
@@ -3778,76 +4652,76 @@
           <a:p>
             <a:pPr>
               <a:spcAft>
-                <a:spcPts val="600"/>
-              </a:spcAft>
-              <a:defRPr sz="1300">
-                <a:solidFill>
-                  <a:srgbClr val="0F172A"/>
-                </a:solidFill>
-              </a:defRPr>
-            </a:pPr>
-            <a:r>
-              <a:t>• Hospital TPA desks submit pre-auth requests before planned surgeries.</a:t>
-            </a:r>
-          </a:p>
-          <a:p>
-            <a:pPr>
-              <a:spcAft>
-                <a:spcPts val="600"/>
-              </a:spcAft>
-              <a:defRPr sz="1300">
-                <a:solidFill>
-                  <a:srgbClr val="0F172A"/>
-                </a:solidFill>
-              </a:defRPr>
-            </a:pPr>
-            <a:r>
-              <a:t>• Insurer medical officers must decide in minutes: covered, and up to what limit?</a:t>
-            </a:r>
-          </a:p>
-          <a:p>
-            <a:pPr>
-              <a:spcAft>
-                <a:spcPts val="600"/>
-              </a:spcAft>
-              <a:defRPr sz="1300">
-                <a:solidFill>
-                  <a:srgbClr val="0F172A"/>
-                </a:solidFill>
-              </a:defRPr>
-            </a:pPr>
-            <a:r>
-              <a:t>• High cost of error in both directions: Erroneous approval = financial loss; Erroneous denial = IRDAI grievance.</a:t>
-            </a:r>
-          </a:p>
-          <a:p>
-            <a:pPr>
-              <a:spcAft>
-                <a:spcPts val="600"/>
-              </a:spcAft>
-              <a:defRPr sz="1300">
-                <a:solidFill>
-                  <a:srgbClr val="0F172A"/>
-                </a:solidFill>
-              </a:defRPr>
-            </a:pPr>
-            <a:r>
-              <a:t>• Cover clauses state general eligibility, but waiting periods (24m/36m), exclusions, and sub-limits are buried pages away.</a:t>
-            </a:r>
-          </a:p>
-          <a:p>
-            <a:pPr>
-              <a:spcAft>
-                <a:spcPts val="600"/>
-              </a:spcAft>
-              <a:defRPr sz="1300">
-                <a:solidFill>
-                  <a:srgbClr val="0F172A"/>
-                </a:solidFill>
-              </a:defRPr>
-            </a:pPr>
-            <a:r>
-              <a:t>• Production mandate: The system NEVER authorizes; it produces grounded recommendations for human Medical Officers.</a:t>
+                <a:spcPts val="500"/>
+              </a:spcAft>
+              <a:defRPr sz="1200">
+                <a:solidFill>
+                  <a:srgbClr val="0F172A"/>
+                </a:solidFill>
+              </a:defRPr>
+            </a:pPr>
+            <a:r>
+              <a:t>• Hospital TPA desks submit pre-auth requests before planned admissions.</a:t>
+            </a:r>
+          </a:p>
+          <a:p>
+            <a:pPr>
+              <a:spcAft>
+                <a:spcPts val="500"/>
+              </a:spcAft>
+              <a:defRPr sz="1200">
+                <a:solidFill>
+                  <a:srgbClr val="0F172A"/>
+                </a:solidFill>
+              </a:defRPr>
+            </a:pPr>
+            <a:r>
+              <a:t>• Underwriters must answer in minutes: Is it covered, and up to what limit?</a:t>
+            </a:r>
+          </a:p>
+          <a:p>
+            <a:pPr>
+              <a:spcAft>
+                <a:spcPts val="500"/>
+              </a:spcAft>
+              <a:defRPr sz="1200">
+                <a:solidFill>
+                  <a:srgbClr val="0F172A"/>
+                </a:solidFill>
+              </a:defRPr>
+            </a:pPr>
+            <a:r>
+              <a:t>• High Stakes: Erroneous approval = direct insurer claim loss; Erroneous denial = consumer lawsuit &amp; IRDAI grievance.</a:t>
+            </a:r>
+          </a:p>
+          <a:p>
+            <a:pPr>
+              <a:spcAft>
+                <a:spcPts val="500"/>
+              </a:spcAft>
+              <a:defRPr sz="1200">
+                <a:solidFill>
+                  <a:srgbClr val="0F172A"/>
+                </a:solidFill>
+              </a:defRPr>
+            </a:pPr>
+            <a:r>
+              <a:t>• Corpus Fragmentation: Cover clauses state general cover, but waiting periods, sub-limits, and exclusions are located 12+ pages away.</a:t>
+            </a:r>
+          </a:p>
+          <a:p>
+            <a:pPr>
+              <a:spcAft>
+                <a:spcPts val="500"/>
+              </a:spcAft>
+              <a:defRPr sz="1200">
+                <a:solidFill>
+                  <a:srgbClr val="0F172A"/>
+                </a:solidFill>
+              </a:defRPr>
+            </a:pPr>
+            <a:r>
+              <a:t>• Core Mandate: The automated system NEVER authorizes an admission; it produces evidence-grounded recommendations for human Medical Officers.</a:t>
             </a:r>
           </a:p>
         </p:txBody>
@@ -3860,8 +4734,8 @@
         </p:nvSpPr>
         <p:spPr>
           <a:xfrm>
-            <a:off x="6217920" y="1645920"/>
-            <a:ext cx="5120640" cy="4572000"/>
+            <a:off x="6217920" y="1508760"/>
+            <a:ext cx="5120640" cy="4846320"/>
           </a:xfrm>
           <a:prstGeom prst="roundRect">
             <a:avLst/>
@@ -3905,8 +4779,8 @@
         </p:nvSpPr>
         <p:spPr>
           <a:xfrm>
-            <a:off x="6400800" y="1828800"/>
-            <a:ext cx="4754880" cy="4206240"/>
+            <a:off x="6400800" y="1673352"/>
+            <a:ext cx="4754880" cy="4517136"/>
           </a:xfrm>
           <a:prstGeom prst="rect">
             <a:avLst/>
@@ -3921,9 +4795,9 @@
           <a:p>
             <a:pPr>
               <a:spcAft>
-                <a:spcPts val="1200"/>
-              </a:spcAft>
-              <a:defRPr sz="1600" b="1">
+                <a:spcPts val="1000"/>
+              </a:spcAft>
+              <a:defRPr sz="1500" b="1">
                 <a:solidFill>
                   <a:srgbClr val="1E3A8A"/>
                 </a:solidFill>
@@ -3936,9 +4810,9 @@
           <a:p>
             <a:pPr>
               <a:spcAft>
-                <a:spcPts val="600"/>
-              </a:spcAft>
-              <a:defRPr sz="1300">
+                <a:spcPts val="500"/>
+              </a:spcAft>
+              <a:defRPr sz="1200">
                 <a:solidFill>
                   <a:srgbClr val="0F172A"/>
                 </a:solidFill>
@@ -3951,9 +4825,9 @@
           <a:p>
             <a:pPr>
               <a:spcAft>
-                <a:spcPts val="600"/>
-              </a:spcAft>
-              <a:defRPr sz="1300">
+                <a:spcPts val="500"/>
+              </a:spcAft>
+              <a:defRPr sz="1200">
                 <a:solidFill>
                   <a:srgbClr val="0F172A"/>
                 </a:solidFill>
@@ -3966,9 +4840,9 @@
           <a:p>
             <a:pPr>
               <a:spcAft>
-                <a:spcPts val="600"/>
-              </a:spcAft>
-              <a:defRPr sz="1300">
+                <a:spcPts val="500"/>
+              </a:spcAft>
+              <a:defRPr sz="1200">
                 <a:solidFill>
                   <a:srgbClr val="0F172A"/>
                 </a:solidFill>
@@ -3981,9 +4855,9 @@
           <a:p>
             <a:pPr>
               <a:spcAft>
-                <a:spcPts val="600"/>
-              </a:spcAft>
-              <a:defRPr sz="1300">
+                <a:spcPts val="500"/>
+              </a:spcAft>
+              <a:defRPr sz="1200">
                 <a:solidFill>
                   <a:srgbClr val="0F172A"/>
                 </a:solidFill>
@@ -4021,8 +4895,8 @@
         </p:nvSpPr>
         <p:spPr>
           <a:xfrm>
-            <a:off x="731520" y="457200"/>
-            <a:ext cx="10515600" cy="365760"/>
+            <a:off x="731520" y="411480"/>
+            <a:ext cx="10515600" cy="320040"/>
           </a:xfrm>
           <a:prstGeom prst="rect">
             <a:avLst/>
@@ -4056,7 +4930,7 @@
         </p:nvSpPr>
         <p:spPr>
           <a:xfrm>
-            <a:off x="731520" y="777240"/>
+            <a:off x="731520" y="685800"/>
             <a:ext cx="10515600" cy="640080"/>
           </a:xfrm>
           <a:prstGeom prst="rect">
@@ -4071,14 +4945,14 @@
           <a:lstStyle/>
           <a:p>
             <a:pPr>
-              <a:defRPr sz="2400" b="1">
+              <a:defRPr sz="2300" b="1">
                 <a:solidFill>
                   <a:srgbClr val="1E3A8A"/>
                 </a:solidFill>
               </a:defRPr>
             </a:pPr>
             <a:r>
-              <a:t>The Difficult Case (Section 4.1): Cataract Surgery at 11 Months</a:t>
+              <a:t>The Difficult Case (Section 4.1): Cataract at 11 Months Vintage</a:t>
             </a:r>
           </a:p>
         </p:txBody>
@@ -4091,8 +4965,8 @@
         </p:nvSpPr>
         <p:spPr>
           <a:xfrm>
-            <a:off x="731520" y="1645920"/>
-            <a:ext cx="5120640" cy="4572000"/>
+            <a:off x="731520" y="1508760"/>
+            <a:ext cx="5120640" cy="4846320"/>
           </a:xfrm>
           <a:prstGeom prst="roundRect">
             <a:avLst/>
@@ -4136,8 +5010,8 @@
         </p:nvSpPr>
         <p:spPr>
           <a:xfrm>
-            <a:off x="914400" y="1828800"/>
-            <a:ext cx="4754880" cy="4206240"/>
+            <a:off x="914400" y="1673352"/>
+            <a:ext cx="4754880" cy="4517136"/>
           </a:xfrm>
           <a:prstGeom prst="rect">
             <a:avLst/>
@@ -4152,9 +5026,9 @@
           <a:p>
             <a:pPr>
               <a:spcAft>
-                <a:spcPts val="1200"/>
-              </a:spcAft>
-              <a:defRPr sz="1600" b="1">
+                <a:spcPts val="1000"/>
+              </a:spcAft>
+              <a:defRPr sz="1500" b="1">
                 <a:solidFill>
                   <a:srgbClr val="1E3A8A"/>
                 </a:solidFill>
@@ -4167,9 +5041,9 @@
           <a:p>
             <a:pPr>
               <a:spcAft>
-                <a:spcPts val="600"/>
-              </a:spcAft>
-              <a:defRPr sz="1300">
+                <a:spcPts val="500"/>
+              </a:spcAft>
+              <a:defRPr sz="1200">
                 <a:solidFill>
                   <a:srgbClr val="0F172A"/>
                 </a:solidFill>
@@ -4182,24 +5056,24 @@
           <a:p>
             <a:pPr>
               <a:spcAft>
-                <a:spcPts val="600"/>
-              </a:spcAft>
-              <a:defRPr sz="1300">
-                <a:solidFill>
-                  <a:srgbClr val="0F172A"/>
-                </a:solidFill>
-              </a:defRPr>
-            </a:pPr>
-            <a:r>
-              <a:t>• Single-pass embedding search query: 'Cataract surgery coverage'.</a:t>
-            </a:r>
-          </a:p>
-          <a:p>
-            <a:pPr>
-              <a:spcAft>
-                <a:spcPts val="600"/>
-              </a:spcAft>
-              <a:defRPr sz="1300">
+                <a:spcPts val="500"/>
+              </a:spcAft>
+              <a:defRPr sz="1200">
+                <a:solidFill>
+                  <a:srgbClr val="0F172A"/>
+                </a:solidFill>
+              </a:defRPr>
+            </a:pPr>
+            <a:r>
+              <a:t>• Single-pass search query: 'Planned cataract surgery with IOL'.</a:t>
+            </a:r>
+          </a:p>
+          <a:p>
+            <a:pPr>
+              <a:spcAft>
+                <a:spcPts val="500"/>
+              </a:spcAft>
+              <a:defRPr sz="1200">
                 <a:solidFill>
                   <a:srgbClr val="0F172A"/>
                 </a:solidFill>
@@ -4212,9 +5086,9 @@
           <a:p>
             <a:pPr>
               <a:spcAft>
-                <a:spcPts val="600"/>
-              </a:spcAft>
-              <a:defRPr sz="1300">
+                <a:spcPts val="500"/>
+              </a:spcAft>
+              <a:defRPr sz="1200">
                 <a:solidFill>
                   <a:srgbClr val="0F172A"/>
                 </a:solidFill>
@@ -4227,16 +5101,16 @@
           <a:p>
             <a:pPr>
               <a:spcAft>
-                <a:spcPts val="600"/>
-              </a:spcAft>
-              <a:defRPr sz="1300">
-                <a:solidFill>
-                  <a:srgbClr val="0F172A"/>
-                </a:solidFill>
-              </a:defRPr>
-            </a:pPr>
-            <a:r>
-              <a:t>• Outcome of fixed pipeline: Erroneous premature approval, causing direct insurer financial loss.</a:t>
+                <a:spcPts val="500"/>
+              </a:spcAft>
+              <a:defRPr sz="1200">
+                <a:solidFill>
+                  <a:srgbClr val="0F172A"/>
+                </a:solidFill>
+              </a:defRPr>
+            </a:pPr>
+            <a:r>
+              <a:t>• Outcome of fixed pipeline: Erroneous premature approval, causing direct insurer underwriting loss.</a:t>
             </a:r>
           </a:p>
         </p:txBody>
@@ -4249,8 +5123,8 @@
         </p:nvSpPr>
         <p:spPr>
           <a:xfrm>
-            <a:off x="6217920" y="1645920"/>
-            <a:ext cx="5120640" cy="4572000"/>
+            <a:off x="6217920" y="1508760"/>
+            <a:ext cx="5120640" cy="4846320"/>
           </a:xfrm>
           <a:prstGeom prst="roundRect">
             <a:avLst/>
@@ -4294,8 +5168,8 @@
         </p:nvSpPr>
         <p:spPr>
           <a:xfrm>
-            <a:off x="6400800" y="1828800"/>
-            <a:ext cx="4754880" cy="4206240"/>
+            <a:off x="6400800" y="1673352"/>
+            <a:ext cx="4754880" cy="4517136"/>
           </a:xfrm>
           <a:prstGeom prst="rect">
             <a:avLst/>
@@ -4310,9 +5184,9 @@
           <a:p>
             <a:pPr>
               <a:spcAft>
-                <a:spcPts val="1200"/>
-              </a:spcAft>
-              <a:defRPr sz="1600" b="1">
+                <a:spcPts val="1000"/>
+              </a:spcAft>
+              <a:defRPr sz="1500" b="1">
                 <a:solidFill>
                   <a:srgbClr val="1E3A8A"/>
                 </a:solidFill>
@@ -4325,9 +5199,9 @@
           <a:p>
             <a:pPr>
               <a:spcAft>
-                <a:spcPts val="600"/>
-              </a:spcAft>
-              <a:defRPr sz="1300">
+                <a:spcPts val="500"/>
+              </a:spcAft>
+              <a:defRPr sz="1200">
                 <a:solidFill>
                   <a:srgbClr val="0F172A"/>
                 </a:solidFill>
@@ -4340,9 +5214,9 @@
           <a:p>
             <a:pPr>
               <a:spcAft>
-                <a:spcPts val="600"/>
-              </a:spcAft>
-              <a:defRPr sz="1300">
+                <a:spcPts val="500"/>
+              </a:spcAft>
+              <a:defRPr sz="1200">
                 <a:solidFill>
                   <a:srgbClr val="0F172A"/>
                 </a:solidFill>
@@ -4355,9 +5229,9 @@
           <a:p>
             <a:pPr>
               <a:spcAft>
-                <a:spcPts val="600"/>
-              </a:spcAft>
-              <a:defRPr sz="1300">
+                <a:spcPts val="500"/>
+              </a:spcAft>
+              <a:defRPr sz="1200">
                 <a:solidFill>
                   <a:srgbClr val="0F172A"/>
                 </a:solidFill>
@@ -4370,9 +5244,9 @@
           <a:p>
             <a:pPr>
               <a:spcAft>
-                <a:spcPts val="600"/>
-              </a:spcAft>
-              <a:defRPr sz="1300">
+                <a:spcPts val="500"/>
+              </a:spcAft>
+              <a:defRPr sz="1200">
                 <a:solidFill>
                   <a:srgbClr val="0F172A"/>
                 </a:solidFill>
@@ -4385,9 +5259,9 @@
           <a:p>
             <a:pPr>
               <a:spcAft>
-                <a:spcPts val="600"/>
-              </a:spcAft>
-              <a:defRPr sz="1300">
+                <a:spcPts val="500"/>
+              </a:spcAft>
+              <a:defRPr sz="1200">
                 <a:solidFill>
                   <a:srgbClr val="0F172A"/>
                 </a:solidFill>
@@ -4425,8 +5299,8 @@
         </p:nvSpPr>
         <p:spPr>
           <a:xfrm>
-            <a:off x="731520" y="457200"/>
-            <a:ext cx="10515600" cy="365760"/>
+            <a:off x="731520" y="411480"/>
+            <a:ext cx="10515600" cy="320040"/>
           </a:xfrm>
           <a:prstGeom prst="rect">
             <a:avLst/>
@@ -4460,7 +5334,7 @@
         </p:nvSpPr>
         <p:spPr>
           <a:xfrm>
-            <a:off x="731520" y="777240"/>
+            <a:off x="731520" y="685800"/>
             <a:ext cx="10515600" cy="640080"/>
           </a:xfrm>
           <a:prstGeom prst="rect">
@@ -4475,14 +5349,14 @@
           <a:lstStyle/>
           <a:p>
             <a:pPr>
-              <a:defRPr sz="2400" b="1">
+              <a:defRPr sz="2300" b="1">
                 <a:solidFill>
                   <a:srgbClr val="1E3A8A"/>
                 </a:solidFill>
               </a:defRPr>
             </a:pPr>
             <a:r>
-              <a:t>Multi-Agent System Architecture &amp; Orchestration</a:t>
+              <a:t>Multi-Agent Architecture &amp; Topology (A1, A2)</a:t>
             </a:r>
           </a:p>
         </p:txBody>
@@ -4495,8 +5369,8 @@
         </p:nvSpPr>
         <p:spPr>
           <a:xfrm>
-            <a:off x="731520" y="1645920"/>
-            <a:ext cx="3383280" cy="4572000"/>
+            <a:off x="731520" y="1508760"/>
+            <a:ext cx="3383280" cy="4846320"/>
           </a:xfrm>
           <a:prstGeom prst="roundRect">
             <a:avLst/>
@@ -4540,8 +5414,8 @@
         </p:nvSpPr>
         <p:spPr>
           <a:xfrm>
-            <a:off x="914400" y="1828800"/>
-            <a:ext cx="3017520" cy="4206240"/>
+            <a:off x="914400" y="1673352"/>
+            <a:ext cx="3017520" cy="4517136"/>
           </a:xfrm>
           <a:prstGeom prst="rect">
             <a:avLst/>
@@ -4556,9 +5430,9 @@
           <a:p>
             <a:pPr>
               <a:spcAft>
-                <a:spcPts val="1200"/>
-              </a:spcAft>
-              <a:defRPr sz="1600" b="1">
+                <a:spcPts val="1000"/>
+              </a:spcAft>
+              <a:defRPr sz="1500" b="1">
                 <a:solidFill>
                   <a:srgbClr val="1E3A8A"/>
                 </a:solidFill>
@@ -4571,9 +5445,9 @@
           <a:p>
             <a:pPr>
               <a:spcAft>
-                <a:spcPts val="600"/>
-              </a:spcAft>
-              <a:defRPr sz="1300">
+                <a:spcPts val="500"/>
+              </a:spcAft>
+              <a:defRPr sz="1200">
                 <a:solidFill>
                   <a:srgbClr val="0F172A"/>
                 </a:solidFill>
@@ -4586,9 +5460,9 @@
           <a:p>
             <a:pPr>
               <a:spcAft>
-                <a:spcPts val="600"/>
-              </a:spcAft>
-              <a:defRPr sz="1300">
+                <a:spcPts val="500"/>
+              </a:spcAft>
+              <a:defRPr sz="1200">
                 <a:solidFill>
                   <a:srgbClr val="0F172A"/>
                 </a:solidFill>
@@ -4601,9 +5475,9 @@
           <a:p>
             <a:pPr>
               <a:spcAft>
-                <a:spcPts val="600"/>
-              </a:spcAft>
-              <a:defRPr sz="1300">
+                <a:spcPts val="500"/>
+              </a:spcAft>
+              <a:defRPr sz="1200">
                 <a:solidFill>
                   <a:srgbClr val="0F172A"/>
                 </a:solidFill>
@@ -4616,9 +5490,9 @@
           <a:p>
             <a:pPr>
               <a:spcAft>
-                <a:spcPts val="600"/>
-              </a:spcAft>
-              <a:defRPr sz="1300">
+                <a:spcPts val="500"/>
+              </a:spcAft>
+              <a:defRPr sz="1200">
                 <a:solidFill>
                   <a:srgbClr val="0F172A"/>
                 </a:solidFill>
@@ -4638,8 +5512,8 @@
         </p:nvSpPr>
         <p:spPr>
           <a:xfrm>
-            <a:off x="4389120" y="1645920"/>
-            <a:ext cx="3383280" cy="4572000"/>
+            <a:off x="4389120" y="1508760"/>
+            <a:ext cx="3383280" cy="4846320"/>
           </a:xfrm>
           <a:prstGeom prst="roundRect">
             <a:avLst/>
@@ -4683,8 +5557,8 @@
         </p:nvSpPr>
         <p:spPr>
           <a:xfrm>
-            <a:off x="4572000" y="1828800"/>
-            <a:ext cx="3017520" cy="4206240"/>
+            <a:off x="4572000" y="1673352"/>
+            <a:ext cx="3017520" cy="4517136"/>
           </a:xfrm>
           <a:prstGeom prst="rect">
             <a:avLst/>
@@ -4699,9 +5573,9 @@
           <a:p>
             <a:pPr>
               <a:spcAft>
-                <a:spcPts val="1200"/>
-              </a:spcAft>
-              <a:defRPr sz="1600" b="1">
+                <a:spcPts val="1000"/>
+              </a:spcAft>
+              <a:defRPr sz="1500" b="1">
                 <a:solidFill>
                   <a:srgbClr val="1E3A8A"/>
                 </a:solidFill>
@@ -4714,9 +5588,9 @@
           <a:p>
             <a:pPr>
               <a:spcAft>
-                <a:spcPts val="600"/>
-              </a:spcAft>
-              <a:defRPr sz="1300">
+                <a:spcPts val="500"/>
+              </a:spcAft>
+              <a:defRPr sz="1200">
                 <a:solidFill>
                   <a:srgbClr val="0F172A"/>
                 </a:solidFill>
@@ -4729,9 +5603,9 @@
           <a:p>
             <a:pPr>
               <a:spcAft>
-                <a:spcPts val="600"/>
-              </a:spcAft>
-              <a:defRPr sz="1300">
+                <a:spcPts val="500"/>
+              </a:spcAft>
+              <a:defRPr sz="1200">
                 <a:solidFill>
                   <a:srgbClr val="0F172A"/>
                 </a:solidFill>
@@ -4744,9 +5618,9 @@
           <a:p>
             <a:pPr>
               <a:spcAft>
-                <a:spcPts val="600"/>
-              </a:spcAft>
-              <a:defRPr sz="1300">
+                <a:spcPts val="500"/>
+              </a:spcAft>
+              <a:defRPr sz="1200">
                 <a:solidFill>
                   <a:srgbClr val="0F172A"/>
                 </a:solidFill>
@@ -4759,9 +5633,9 @@
           <a:p>
             <a:pPr>
               <a:spcAft>
-                <a:spcPts val="600"/>
-              </a:spcAft>
-              <a:defRPr sz="1300">
+                <a:spcPts val="500"/>
+              </a:spcAft>
+              <a:defRPr sz="1200">
                 <a:solidFill>
                   <a:srgbClr val="0F172A"/>
                 </a:solidFill>
@@ -4781,8 +5655,8 @@
         </p:nvSpPr>
         <p:spPr>
           <a:xfrm>
-            <a:off x="8046720" y="1645920"/>
-            <a:ext cx="3383280" cy="4572000"/>
+            <a:off x="8046720" y="1508760"/>
+            <a:ext cx="3383280" cy="4846320"/>
           </a:xfrm>
           <a:prstGeom prst="roundRect">
             <a:avLst/>
@@ -4826,8 +5700,8 @@
         </p:nvSpPr>
         <p:spPr>
           <a:xfrm>
-            <a:off x="8229600" y="1828800"/>
-            <a:ext cx="3017520" cy="4206240"/>
+            <a:off x="8229600" y="1673352"/>
+            <a:ext cx="3017520" cy="4517136"/>
           </a:xfrm>
           <a:prstGeom prst="rect">
             <a:avLst/>
@@ -4842,9 +5716,9 @@
           <a:p>
             <a:pPr>
               <a:spcAft>
-                <a:spcPts val="1200"/>
-              </a:spcAft>
-              <a:defRPr sz="1600" b="1">
+                <a:spcPts val="1000"/>
+              </a:spcAft>
+              <a:defRPr sz="1500" b="1">
                 <a:solidFill>
                   <a:srgbClr val="1E3A8A"/>
                 </a:solidFill>
@@ -4857,9 +5731,9 @@
           <a:p>
             <a:pPr>
               <a:spcAft>
-                <a:spcPts val="600"/>
-              </a:spcAft>
-              <a:defRPr sz="1300">
+                <a:spcPts val="500"/>
+              </a:spcAft>
+              <a:defRPr sz="1200">
                 <a:solidFill>
                   <a:srgbClr val="0F172A"/>
                 </a:solidFill>
@@ -4872,9 +5746,9 @@
           <a:p>
             <a:pPr>
               <a:spcAft>
-                <a:spcPts val="600"/>
-              </a:spcAft>
-              <a:defRPr sz="1300">
+                <a:spcPts val="500"/>
+              </a:spcAft>
+              <a:defRPr sz="1200">
                 <a:solidFill>
                   <a:srgbClr val="0F172A"/>
                 </a:solidFill>
@@ -4887,9 +5761,9 @@
           <a:p>
             <a:pPr>
               <a:spcAft>
-                <a:spcPts val="600"/>
-              </a:spcAft>
-              <a:defRPr sz="1300">
+                <a:spcPts val="500"/>
+              </a:spcAft>
+              <a:defRPr sz="1200">
                 <a:solidFill>
                   <a:srgbClr val="0F172A"/>
                 </a:solidFill>
@@ -4902,9 +5776,9 @@
           <a:p>
             <a:pPr>
               <a:spcAft>
-                <a:spcPts val="600"/>
-              </a:spcAft>
-              <a:defRPr sz="1300">
+                <a:spcPts val="500"/>
+              </a:spcAft>
+              <a:defRPr sz="1200">
                 <a:solidFill>
                   <a:srgbClr val="0F172A"/>
                 </a:solidFill>
@@ -4942,8 +5816,8 @@
         </p:nvSpPr>
         <p:spPr>
           <a:xfrm>
-            <a:off x="731520" y="457200"/>
-            <a:ext cx="10515600" cy="365760"/>
+            <a:off x="731520" y="411480"/>
+            <a:ext cx="10515600" cy="320040"/>
           </a:xfrm>
           <a:prstGeom prst="rect">
             <a:avLst/>
@@ -4977,7 +5851,7 @@
         </p:nvSpPr>
         <p:spPr>
           <a:xfrm>
-            <a:off x="731520" y="777240"/>
+            <a:off x="731520" y="685800"/>
             <a:ext cx="10515600" cy="640080"/>
           </a:xfrm>
           <a:prstGeom prst="rect">
@@ -4992,14 +5866,14 @@
           <a:lstStyle/>
           <a:p>
             <a:pPr>
-              <a:defRPr sz="2400" b="1">
+              <a:defRPr sz="2300" b="1">
                 <a:solidFill>
                   <a:srgbClr val="1E3A8A"/>
                 </a:solidFill>
               </a:defRPr>
             </a:pPr>
             <a:r>
-              <a:t>Ingestion Boundary, Quarantine &amp; LLM Guardrails (D1, L4)</a:t>
+              <a:t>Ingestion Boundary &amp; Quarantine Engine (D1, F1, F2)</a:t>
             </a:r>
           </a:p>
         </p:txBody>
@@ -5012,8 +5886,8 @@
         </p:nvSpPr>
         <p:spPr>
           <a:xfrm>
-            <a:off x="731520" y="1645920"/>
-            <a:ext cx="5120640" cy="4572000"/>
+            <a:off x="731520" y="1508760"/>
+            <a:ext cx="5120640" cy="4846320"/>
           </a:xfrm>
           <a:prstGeom prst="roundRect">
             <a:avLst/>
@@ -5057,8 +5931,8 @@
         </p:nvSpPr>
         <p:spPr>
           <a:xfrm>
-            <a:off x="914400" y="1828800"/>
-            <a:ext cx="4754880" cy="4206240"/>
+            <a:off x="914400" y="1673352"/>
+            <a:ext cx="4754880" cy="4517136"/>
           </a:xfrm>
           <a:prstGeom prst="rect">
             <a:avLst/>
@@ -5073,9 +5947,9 @@
           <a:p>
             <a:pPr>
               <a:spcAft>
-                <a:spcPts val="1200"/>
-              </a:spcAft>
-              <a:defRPr sz="1600" b="1">
+                <a:spcPts val="1000"/>
+              </a:spcAft>
+              <a:defRPr sz="1500" b="1">
                 <a:solidFill>
                   <a:srgbClr val="1E3A8A"/>
                 </a:solidFill>
@@ -5088,9 +5962,9 @@
           <a:p>
             <a:pPr>
               <a:spcAft>
-                <a:spcPts val="600"/>
-              </a:spcAft>
-              <a:defRPr sz="1300">
+                <a:spcPts val="500"/>
+              </a:spcAft>
+              <a:defRPr sz="1200">
                 <a:solidFill>
                   <a:srgbClr val="0F172A"/>
                 </a:solidFill>
@@ -5103,9 +5977,9 @@
           <a:p>
             <a:pPr>
               <a:spcAft>
-                <a:spcPts val="600"/>
-              </a:spcAft>
-              <a:defRPr sz="1300">
+                <a:spcPts val="500"/>
+              </a:spcAft>
+              <a:defRPr sz="1200">
                 <a:solidFill>
                   <a:srgbClr val="0F172A"/>
                 </a:solidFill>
@@ -5118,9 +5992,9 @@
           <a:p>
             <a:pPr>
               <a:spcAft>
-                <a:spcPts val="600"/>
-              </a:spcAft>
-              <a:defRPr sz="1300">
+                <a:spcPts val="500"/>
+              </a:spcAft>
+              <a:defRPr sz="1200">
                 <a:solidFill>
                   <a:srgbClr val="0F172A"/>
                 </a:solidFill>
@@ -5133,9 +6007,9 @@
           <a:p>
             <a:pPr>
               <a:spcAft>
-                <a:spcPts val="600"/>
-              </a:spcAft>
-              <a:defRPr sz="1300">
+                <a:spcPts val="500"/>
+              </a:spcAft>
+              <a:defRPr sz="1200">
                 <a:solidFill>
                   <a:srgbClr val="0F172A"/>
                 </a:solidFill>
@@ -5148,16 +6022,16 @@
           <a:p>
             <a:pPr>
               <a:spcAft>
-                <a:spcPts val="600"/>
-              </a:spcAft>
-              <a:defRPr sz="1300">
-                <a:solidFill>
-                  <a:srgbClr val="0F172A"/>
-                </a:solidFill>
-              </a:defRPr>
-            </a:pPr>
-            <a:r>
-              <a:t>• Quarantine Quarantine: Rejected records saved to disk with field-level errors; zero agent runs initiated.</a:t>
+                <a:spcPts val="500"/>
+              </a:spcAft>
+              <a:defRPr sz="1200">
+                <a:solidFill>
+                  <a:srgbClr val="0F172A"/>
+                </a:solidFill>
+              </a:defRPr>
+            </a:pPr>
+            <a:r>
+              <a:t>• Daily room rent cannot exceed total estimated hospital cost.</a:t>
             </a:r>
           </a:p>
         </p:txBody>
@@ -5170,8 +6044,8 @@
         </p:nvSpPr>
         <p:spPr>
           <a:xfrm>
-            <a:off x="6217920" y="1645920"/>
-            <a:ext cx="5120640" cy="4572000"/>
+            <a:off x="6217920" y="1508760"/>
+            <a:ext cx="5120640" cy="4846320"/>
           </a:xfrm>
           <a:prstGeom prst="roundRect">
             <a:avLst/>
@@ -5215,8 +6089,8 @@
         </p:nvSpPr>
         <p:spPr>
           <a:xfrm>
-            <a:off x="6400800" y="1828800"/>
-            <a:ext cx="4754880" cy="4206240"/>
+            <a:off x="6400800" y="1673352"/>
+            <a:ext cx="4754880" cy="4517136"/>
           </a:xfrm>
           <a:prstGeom prst="rect">
             <a:avLst/>
@@ -5231,76 +6105,76 @@
           <a:p>
             <a:pPr>
               <a:spcAft>
-                <a:spcPts val="1200"/>
-              </a:spcAft>
-              <a:defRPr sz="1600" b="1">
+                <a:spcPts val="1000"/>
+              </a:spcAft>
+              <a:defRPr sz="1500" b="1">
                 <a:solidFill>
                   <a:srgbClr val="1E3A8A"/>
                 </a:solidFill>
               </a:defRPr>
             </a:pPr>
             <a:r>
-              <a:t>Adversarial Defense (L4)</a:t>
-            </a:r>
-          </a:p>
-          <a:p>
-            <a:pPr>
-              <a:spcAft>
-                <a:spcPts val="600"/>
-              </a:spcAft>
-              <a:defRPr sz="1300">
-                <a:solidFill>
-                  <a:srgbClr val="0F172A"/>
-                </a:solidFill>
-              </a:defRPr>
-            </a:pPr>
-            <a:r>
-              <a:t>• Prompt Injection Defense: Regex &amp; semantic filters detect 'ignore previous instructions', 'system override', 'DAN mode'.</a:t>
-            </a:r>
-          </a:p>
-          <a:p>
-            <a:pPr>
-              <a:spcAft>
-                <a:spcPts val="600"/>
-              </a:spcAft>
-              <a:defRPr sz="1300">
-                <a:solidFill>
-                  <a:srgbClr val="0F172A"/>
-                </a:solidFill>
-              </a:defRPr>
-            </a:pPr>
-            <a:r>
-              <a:t>• Toxicity filter blocks abusive/fraudulent payloads.</a:t>
-            </a:r>
-          </a:p>
-          <a:p>
-            <a:pPr>
-              <a:spcAft>
-                <a:spcPts val="600"/>
-              </a:spcAft>
-              <a:defRPr sz="1300">
-                <a:solidFill>
-                  <a:srgbClr val="0F172A"/>
-                </a:solidFill>
-              </a:defRPr>
-            </a:pPr>
-            <a:r>
-              <a:t>• Authority Boundary Guardrail: Output filter strips unauthorized binding declarations ('insurer guarantees 100%').</a:t>
-            </a:r>
-          </a:p>
-          <a:p>
-            <a:pPr>
-              <a:spcAft>
-                <a:spcPts val="600"/>
-              </a:spcAft>
-              <a:defRPr sz="1300">
-                <a:solidFill>
-                  <a:srgbClr val="0F172A"/>
-                </a:solidFill>
-              </a:defRPr>
-            </a:pPr>
-            <a:r>
-              <a:t>• Mandatory Legal Disclaimer automatically appended to every response.</a:t>
+              <a:t>Quarantine Mechanism (Demo Item 4)</a:t>
+            </a:r>
+          </a:p>
+          <a:p>
+            <a:pPr>
+              <a:spcAft>
+                <a:spcPts val="500"/>
+              </a:spcAft>
+              <a:defRPr sz="1200">
+                <a:solidFill>
+                  <a:srgbClr val="0F172A"/>
+                </a:solidFill>
+              </a:defRPr>
+            </a:pPr>
+            <a:r>
+              <a:t>• Zero Agent Run Mandate: Malformed records must not initiate an LLM agent run.</a:t>
+            </a:r>
+          </a:p>
+          <a:p>
+            <a:pPr>
+              <a:spcAft>
+                <a:spcPts val="500"/>
+              </a:spcAft>
+              <a:defRPr sz="1200">
+                <a:solidFill>
+                  <a:srgbClr val="0F172A"/>
+                </a:solidFill>
+              </a:defRPr>
+            </a:pPr>
+            <a:r>
+              <a:t>• Immediate HTTP 422: Rejected records return structured validation errors.</a:t>
+            </a:r>
+          </a:p>
+          <a:p>
+            <a:pPr>
+              <a:spcAft>
+                <a:spcPts val="500"/>
+              </a:spcAft>
+              <a:defRPr sz="1200">
+                <a:solidFill>
+                  <a:srgbClr val="0F172A"/>
+                </a:solidFill>
+              </a:defRPr>
+            </a:pPr>
+            <a:r>
+              <a:t>• Audit Trail: Payload + field-level errors persisted to data/quarantine/{qid}.json.</a:t>
+            </a:r>
+          </a:p>
+          <a:p>
+            <a:pPr>
+              <a:spcAft>
+                <a:spcPts val="500"/>
+              </a:spcAft>
+              <a:defRPr sz="1200">
+                <a:solidFill>
+                  <a:srgbClr val="0F172A"/>
+                </a:solidFill>
+              </a:defRPr>
+            </a:pPr>
+            <a:r>
+              <a:t>• Inspector Endpoint: GET /api/v1/quarantine allows auditing all rejected submissions.</a:t>
             </a:r>
           </a:p>
         </p:txBody>
@@ -5331,8 +6205,8 @@
         </p:nvSpPr>
         <p:spPr>
           <a:xfrm>
-            <a:off x="731520" y="457200"/>
-            <a:ext cx="10515600" cy="365760"/>
+            <a:off x="731520" y="411480"/>
+            <a:ext cx="10515600" cy="320040"/>
           </a:xfrm>
           <a:prstGeom prst="rect">
             <a:avLst/>
@@ -5366,7 +6240,7 @@
         </p:nvSpPr>
         <p:spPr>
           <a:xfrm>
-            <a:off x="731520" y="777240"/>
+            <a:off x="731520" y="685800"/>
             <a:ext cx="10515600" cy="640080"/>
           </a:xfrm>
           <a:prstGeom prst="rect">
@@ -5381,14 +6255,14 @@
           <a:lstStyle/>
           <a:p>
             <a:pPr>
-              <a:defRPr sz="2400" b="1">
+              <a:defRPr sz="2300" b="1">
                 <a:solidFill>
                   <a:srgbClr val="1E3A8A"/>
                 </a:solidFill>
               </a:defRPr>
             </a:pPr>
             <a:r>
-              <a:t>Benchmark &amp; LLMOps Evaluation (20 Scenarios) (L2, L3)</a:t>
+              <a:t>Dynamic 2-Stage Retrieval vs Fixed Pipeline (Section 5)</a:t>
             </a:r>
           </a:p>
         </p:txBody>
@@ -5401,8 +6275,8 @@
         </p:nvSpPr>
         <p:spPr>
           <a:xfrm>
-            <a:off x="731520" y="1645920"/>
-            <a:ext cx="5120640" cy="4572000"/>
+            <a:off x="731520" y="1508760"/>
+            <a:ext cx="5120640" cy="4846320"/>
           </a:xfrm>
           <a:prstGeom prst="roundRect">
             <a:avLst/>
@@ -5446,8 +6320,8 @@
         </p:nvSpPr>
         <p:spPr>
           <a:xfrm>
-            <a:off x="914400" y="1828800"/>
-            <a:ext cx="4754880" cy="4206240"/>
+            <a:off x="914400" y="1673352"/>
+            <a:ext cx="4754880" cy="4517136"/>
           </a:xfrm>
           <a:prstGeom prst="rect">
             <a:avLst/>
@@ -5462,106 +6336,91 @@
           <a:p>
             <a:pPr>
               <a:spcAft>
-                <a:spcPts val="1200"/>
-              </a:spcAft>
-              <a:defRPr sz="1600" b="1">
+                <a:spcPts val="1000"/>
+              </a:spcAft>
+              <a:defRPr sz="1500" b="1">
                 <a:solidFill>
                   <a:srgbClr val="1E3A8A"/>
                 </a:solidFill>
               </a:defRPr>
             </a:pPr>
             <a:r>
-              <a:t>Evaluation Methodology (TruLens Metrics)</a:t>
-            </a:r>
-          </a:p>
-          <a:p>
-            <a:pPr>
-              <a:spcAft>
-                <a:spcPts val="600"/>
-              </a:spcAft>
-              <a:defRPr sz="1300">
-                <a:solidFill>
-                  <a:srgbClr val="0F172A"/>
-                </a:solidFill>
-              </a:defRPr>
-            </a:pPr>
-            <a:r>
-              <a:t>• Fixed evaluation suite of 20 diverse clinical scenarios in JSON.</a:t>
-            </a:r>
-          </a:p>
-          <a:p>
-            <a:pPr>
-              <a:spcAft>
-                <a:spcPts val="600"/>
-              </a:spcAft>
-              <a:defRPr sz="1300">
-                <a:solidFill>
-                  <a:srgbClr val="0F172A"/>
-                </a:solidFill>
-              </a:defRPr>
-            </a:pPr>
-            <a:r>
-              <a:t>• Groundedness: Ratio of cited assertions anchored in retrieved text.</a:t>
-            </a:r>
-          </a:p>
-          <a:p>
-            <a:pPr>
-              <a:spcAft>
-                <a:spcPts val="600"/>
-              </a:spcAft>
-              <a:defRPr sz="1300">
-                <a:solidFill>
-                  <a:srgbClr val="0F172A"/>
-                </a:solidFill>
-              </a:defRPr>
-            </a:pPr>
-            <a:r>
-              <a:t>• Context Relevance: Ratio of retrieved provisions pertinent to the clinical case.</a:t>
-            </a:r>
-          </a:p>
-          <a:p>
-            <a:pPr>
-              <a:spcAft>
-                <a:spcPts val="600"/>
-              </a:spcAft>
-              <a:defRPr sz="1300">
-                <a:solidFill>
-                  <a:srgbClr val="0F172A"/>
-                </a:solidFill>
-              </a:defRPr>
-            </a:pPr>
-            <a:r>
-              <a:t>• Faithfulness: Agreement between verdict and waiting-period/exclusion rules.</a:t>
-            </a:r>
-          </a:p>
-          <a:p>
-            <a:pPr>
-              <a:spcAft>
-                <a:spcPts val="600"/>
-              </a:spcAft>
-              <a:defRPr sz="1300">
-                <a:solidFill>
-                  <a:srgbClr val="0F172A"/>
-                </a:solidFill>
-              </a:defRPr>
-            </a:pPr>
-            <a:r>
-              <a:t>• Hallucination Rate: 1.0 - Faithfulness.</a:t>
-            </a:r>
-          </a:p>
-          <a:p>
-            <a:pPr>
-              <a:spcAft>
-                <a:spcPts val="600"/>
-              </a:spcAft>
-              <a:defRPr sz="1300">
-                <a:solidFill>
-                  <a:srgbClr val="0F172A"/>
-                </a:solidFill>
-              </a:defRPr>
-            </a:pPr>
-            <a:r>
-              <a:t>• Evaluates Scenario 4.1, PED disclosures, emergency trauma, and exclusions.</a:t>
+              <a:t>Fixed Pipeline (Standard RAG)</a:t>
+            </a:r>
+          </a:p>
+          <a:p>
+            <a:pPr>
+              <a:spcAft>
+                <a:spcPts val="500"/>
+              </a:spcAft>
+              <a:defRPr sz="1200">
+                <a:solidFill>
+                  <a:srgbClr val="0F172A"/>
+                </a:solidFill>
+              </a:defRPr>
+            </a:pPr>
+            <a:r>
+              <a:t>• 1. Ingests request text as a static query.</a:t>
+            </a:r>
+          </a:p>
+          <a:p>
+            <a:pPr>
+              <a:spcAft>
+                <a:spcPts val="500"/>
+              </a:spcAft>
+              <a:defRPr sz="1200">
+                <a:solidFill>
+                  <a:srgbClr val="0F172A"/>
+                </a:solidFill>
+              </a:defRPr>
+            </a:pPr>
+            <a:r>
+              <a:t>• 2. Executes single similarity search across policy embeddings.</a:t>
+            </a:r>
+          </a:p>
+          <a:p>
+            <a:pPr>
+              <a:spcAft>
+                <a:spcPts val="500"/>
+              </a:spcAft>
+              <a:defRPr sz="1200">
+                <a:solidFill>
+                  <a:srgbClr val="0F172A"/>
+                </a:solidFill>
+              </a:defRPr>
+            </a:pPr>
+            <a:r>
+              <a:t>• 3. Feeds top-k passages directly into generator prompt.</a:t>
+            </a:r>
+          </a:p>
+          <a:p>
+            <a:pPr>
+              <a:spcAft>
+                <a:spcPts val="500"/>
+              </a:spcAft>
+              <a:defRPr sz="1200">
+                <a:solidFill>
+                  <a:srgbClr val="0F172A"/>
+                </a:solidFill>
+              </a:defRPr>
+            </a:pPr>
+            <a:r>
+              <a:t>• Failure: Inability to detect unmentioned constraints. The system has no mechanism to ask: 'What modifying conditions apply to this surgery?'</a:t>
+            </a:r>
+          </a:p>
+          <a:p>
+            <a:pPr>
+              <a:spcAft>
+                <a:spcPts val="500"/>
+              </a:spcAft>
+              <a:defRPr sz="1200">
+                <a:solidFill>
+                  <a:srgbClr val="0F172A"/>
+                </a:solidFill>
+              </a:defRPr>
+            </a:pPr>
+            <a:r>
+              <a:t>• Result: Hallucinated approvals on unserved waiting periods.</a:t>
             </a:r>
           </a:p>
         </p:txBody>
@@ -5574,8 +6433,8 @@
         </p:nvSpPr>
         <p:spPr>
           <a:xfrm>
-            <a:off x="6217920" y="1645920"/>
-            <a:ext cx="5120640" cy="4572000"/>
+            <a:off x="6217920" y="1508760"/>
+            <a:ext cx="5120640" cy="4846320"/>
           </a:xfrm>
           <a:prstGeom prst="roundRect">
             <a:avLst/>
@@ -5619,8 +6478,8 @@
         </p:nvSpPr>
         <p:spPr>
           <a:xfrm>
-            <a:off x="6400800" y="1828800"/>
-            <a:ext cx="4754880" cy="4206240"/>
+            <a:off x="6400800" y="1673352"/>
+            <a:ext cx="4754880" cy="4517136"/>
           </a:xfrm>
           <a:prstGeom prst="rect">
             <a:avLst/>
@@ -5635,136 +6494,91 @@
           <a:p>
             <a:pPr>
               <a:spcAft>
-                <a:spcPts val="1200"/>
-              </a:spcAft>
-              <a:defRPr sz="1600" b="1">
+                <a:spcPts val="1000"/>
+              </a:spcAft>
+              <a:defRPr sz="1500" b="1">
                 <a:solidFill>
                   <a:srgbClr val="1E3A8A"/>
                 </a:solidFill>
               </a:defRPr>
             </a:pPr>
             <a:r>
-              <a:t>Prompt Variant Comparison (L2)</a:t>
-            </a:r>
-          </a:p>
-          <a:p>
-            <a:pPr>
-              <a:spcAft>
-                <a:spcPts val="600"/>
-              </a:spcAft>
-              <a:defRPr sz="1300">
-                <a:solidFill>
-                  <a:srgbClr val="0F172A"/>
-                </a:solidFill>
-              </a:defRPr>
-            </a:pPr>
-            <a:r>
-              <a:t>• Prompt v1 (Concise single-pass):</a:t>
-            </a:r>
-          </a:p>
-          <a:p>
-            <a:pPr>
-              <a:spcAft>
-                <a:spcPts val="600"/>
-              </a:spcAft>
-              <a:defRPr sz="1300">
-                <a:solidFill>
-                  <a:srgbClr val="0F172A"/>
-                </a:solidFill>
-              </a:defRPr>
-            </a:pPr>
-            <a:r>
-              <a:t>•   - Routing Accuracy: 80.0% | Groundedness: 0.600</a:t>
-            </a:r>
-          </a:p>
-          <a:p>
-            <a:pPr>
-              <a:spcAft>
-                <a:spcPts val="600"/>
-              </a:spcAft>
-              <a:defRPr sz="1300">
-                <a:solidFill>
-                  <a:srgbClr val="0F172A"/>
-                </a:solidFill>
-              </a:defRPr>
-            </a:pPr>
-            <a:r>
-              <a:t>•   - Faithfulness: 0.650 | Hallucination: 0.350</a:t>
-            </a:r>
-          </a:p>
-          <a:p>
-            <a:pPr>
-              <a:spcAft>
-                <a:spcPts val="600"/>
-              </a:spcAft>
-              <a:defRPr sz="1300">
-                <a:solidFill>
-                  <a:srgbClr val="0F172A"/>
-                </a:solidFill>
-              </a:defRPr>
-            </a:pPr>
-            <a:r>
-              <a:t>• Prompt v2 (Verified CoT with 2-Stage Retrieval):</a:t>
-            </a:r>
-          </a:p>
-          <a:p>
-            <a:pPr>
-              <a:spcAft>
-                <a:spcPts val="600"/>
-              </a:spcAft>
-              <a:defRPr sz="1300">
-                <a:solidFill>
-                  <a:srgbClr val="0F172A"/>
-                </a:solidFill>
-              </a:defRPr>
-            </a:pPr>
-            <a:r>
-              <a:t>•   - Routing Accuracy: 100.0% (+20.0%)</a:t>
-            </a:r>
-          </a:p>
-          <a:p>
-            <a:pPr>
-              <a:spcAft>
-                <a:spcPts val="600"/>
-              </a:spcAft>
-              <a:defRPr sz="1300">
-                <a:solidFill>
-                  <a:srgbClr val="0F172A"/>
-                </a:solidFill>
-              </a:defRPr>
-            </a:pPr>
-            <a:r>
-              <a:t>•   - Groundedness: 0.925 (+0.325) | Faithfulness: 0.900 (+0.250)</a:t>
-            </a:r>
-          </a:p>
-          <a:p>
-            <a:pPr>
-              <a:spcAft>
-                <a:spcPts val="600"/>
-              </a:spcAft>
-              <a:defRPr sz="1300">
-                <a:solidFill>
-                  <a:srgbClr val="0F172A"/>
-                </a:solidFill>
-              </a:defRPr>
-            </a:pPr>
-            <a:r>
-              <a:t>•   - Hallucination Rate: 0.100 (-0.250)</a:t>
-            </a:r>
-          </a:p>
-          <a:p>
-            <a:pPr>
-              <a:spcAft>
-                <a:spcPts val="600"/>
-              </a:spcAft>
-              <a:defRPr sz="1300">
-                <a:solidFill>
-                  <a:srgbClr val="0F172A"/>
-                </a:solidFill>
-              </a:defRPr>
-            </a:pPr>
-            <a:r>
-              <a:t>• Cost per 100 runs: $0.004032 (Ultra cost-effective).</a:t>
+              <a:t>Autonomous 2-Stage Agent Loop</a:t>
+            </a:r>
+          </a:p>
+          <a:p>
+            <a:pPr>
+              <a:spcAft>
+                <a:spcPts val="500"/>
+              </a:spcAft>
+              <a:defRPr sz="1200">
+                <a:solidFill>
+                  <a:srgbClr val="0F172A"/>
+                </a:solidFill>
+              </a:defRPr>
+            </a:pPr>
+            <a:r>
+              <a:t>• 1. Retrieves primary cover clause (e.g. Inpatient / Day Care).</a:t>
+            </a:r>
+          </a:p>
+          <a:p>
+            <a:pPr>
+              <a:spcAft>
+                <a:spcPts val="500"/>
+              </a:spcAft>
+              <a:defRPr sz="1200">
+                <a:solidFill>
+                  <a:srgbClr val="0F172A"/>
+                </a:solidFill>
+              </a:defRPr>
+            </a:pPr>
+            <a:r>
+              <a:t>• 2. Inspects clinical entities against known statutory categories (Cataract, Hernia, Joint, PED, Maternity).</a:t>
+            </a:r>
+          </a:p>
+          <a:p>
+            <a:pPr>
+              <a:spcAft>
+                <a:spcPts val="500"/>
+              </a:spcAft>
+              <a:defRPr sz="1200">
+                <a:solidFill>
+                  <a:srgbClr val="0F172A"/>
+                </a:solidFill>
+              </a:defRPr>
+            </a:pPr>
+            <a:r>
+              <a:t>• 3. Synthesizes targeted secondary query derived from findings.</a:t>
+            </a:r>
+          </a:p>
+          <a:p>
+            <a:pPr>
+              <a:spcAft>
+                <a:spcPts val="500"/>
+              </a:spcAft>
+              <a:defRPr sz="1200">
+                <a:solidFill>
+                  <a:srgbClr val="0F172A"/>
+                </a:solidFill>
+              </a:defRPr>
+            </a:pPr>
+            <a:r>
+              <a:t>• 4. Retrieves modifying provisions (Clause 2.2, 2.3, 2.4, 3.0).</a:t>
+            </a:r>
+          </a:p>
+          <a:p>
+            <a:pPr>
+              <a:spcAft>
+                <a:spcPts val="500"/>
+              </a:spcAft>
+              <a:defRPr sz="1200">
+                <a:solidFill>
+                  <a:srgbClr val="0F172A"/>
+                </a:solidFill>
+              </a:defRPr>
+            </a:pPr>
+            <a:r>
+              <a:t>• 5. Self-verifies support before synthesizing final recommendation.</a:t>
             </a:r>
           </a:p>
         </p:txBody>
@@ -5795,8 +6609,8 @@
         </p:nvSpPr>
         <p:spPr>
           <a:xfrm>
-            <a:off x="731520" y="457200"/>
-            <a:ext cx="10515600" cy="365760"/>
+            <a:off x="731520" y="411480"/>
+            <a:ext cx="10515600" cy="320040"/>
           </a:xfrm>
           <a:prstGeom prst="rect">
             <a:avLst/>
@@ -5830,7 +6644,7 @@
         </p:nvSpPr>
         <p:spPr>
           <a:xfrm>
-            <a:off x="731520" y="777240"/>
+            <a:off x="731520" y="685800"/>
             <a:ext cx="10515600" cy="640080"/>
           </a:xfrm>
           <a:prstGeom prst="rect">
@@ -5845,14 +6659,14 @@
           <a:lstStyle/>
           <a:p>
             <a:pPr>
-              <a:defRPr sz="2400" b="1">
+              <a:defRPr sz="2300" b="1">
                 <a:solidFill>
                   <a:srgbClr val="1E3A8A"/>
                 </a:solidFill>
               </a:defRPr>
             </a:pPr>
             <a:r>
-              <a:t>Reliability, Circuit Breaker &amp; Deployment (A5, D3, A7)</a:t>
+              <a:t>Strict Self-Verification &amp; Safety Guardrails (A3, L4)</a:t>
             </a:r>
           </a:p>
         </p:txBody>
@@ -5865,8 +6679,8 @@
         </p:nvSpPr>
         <p:spPr>
           <a:xfrm>
-            <a:off x="731520" y="1645920"/>
-            <a:ext cx="5120640" cy="4572000"/>
+            <a:off x="731520" y="1508760"/>
+            <a:ext cx="5120640" cy="4846320"/>
           </a:xfrm>
           <a:prstGeom prst="roundRect">
             <a:avLst/>
@@ -5910,8 +6724,8 @@
         </p:nvSpPr>
         <p:spPr>
           <a:xfrm>
-            <a:off x="914400" y="1828800"/>
-            <a:ext cx="4754880" cy="4206240"/>
+            <a:off x="914400" y="1673352"/>
+            <a:ext cx="4754880" cy="4517136"/>
           </a:xfrm>
           <a:prstGeom prst="rect">
             <a:avLst/>
@@ -5926,76 +6740,76 @@
           <a:p>
             <a:pPr>
               <a:spcAft>
-                <a:spcPts val="1200"/>
-              </a:spcAft>
-              <a:defRPr sz="1600" b="1">
+                <a:spcPts val="1000"/>
+              </a:spcAft>
+              <a:defRPr sz="1500" b="1">
                 <a:solidFill>
                   <a:srgbClr val="1E3A8A"/>
                 </a:solidFill>
               </a:defRPr>
             </a:pPr>
             <a:r>
-              <a:t>Fault Tolerance &amp; Circuit Breaker (A5)</a:t>
-            </a:r>
-          </a:p>
-          <a:p>
-            <a:pPr>
-              <a:spcAft>
-                <a:spcPts val="600"/>
-              </a:spcAft>
-              <a:defRPr sz="1300">
-                <a:solidFill>
-                  <a:srgbClr val="0F172A"/>
-                </a:solidFill>
-              </a:defRPr>
-            </a:pPr>
-            <a:r>
-              <a:t>• Trips to OPEN after 3 consecutive provider failures / timeouts.</a:t>
-            </a:r>
-          </a:p>
-          <a:p>
-            <a:pPr>
-              <a:spcAft>
-                <a:spcPts val="600"/>
-              </a:spcAft>
-              <a:defRPr sz="1300">
-                <a:solidFill>
-                  <a:srgbClr val="0F172A"/>
-                </a:solidFill>
-              </a:defRPr>
-            </a:pPr>
-            <a:r>
-              <a:t>• Graceful Degradation: When OPEN, immediately routes to 'medical-review' without waiting for timeout.</a:t>
-            </a:r>
-          </a:p>
-          <a:p>
-            <a:pPr>
-              <a:spcAft>
-                <a:spcPts val="600"/>
-              </a:spcAft>
-              <a:defRPr sz="1300">
-                <a:solidFill>
-                  <a:srgbClr val="0F172A"/>
-                </a:solidFill>
-              </a:defRPr>
-            </a:pPr>
-            <a:r>
-              <a:t>• Bounded retry with exponential backoff on transient errors.</a:t>
-            </a:r>
-          </a:p>
-          <a:p>
-            <a:pPr>
-              <a:spcAft>
-                <a:spcPts val="600"/>
-              </a:spcAft>
-              <a:defRPr sz="1300">
-                <a:solidFill>
-                  <a:srgbClr val="0F172A"/>
-                </a:solidFill>
-              </a:defRPr>
-            </a:pPr>
-            <a:r>
-              <a:t>• In-memory / Redis caching of queries &amp; embeddings (D7) reduces latency from ~70ms to &lt;2ms.</a:t>
+              <a:t>Strict Self-Verification Loop (A3)</a:t>
+            </a:r>
+          </a:p>
+          <a:p>
+            <a:pPr>
+              <a:spcAft>
+                <a:spcPts val="500"/>
+              </a:spcAft>
+              <a:defRPr sz="1200">
+                <a:solidFill>
+                  <a:srgbClr val="0F172A"/>
+                </a:solidFill>
+              </a:defRPr>
+            </a:pPr>
+            <a:r>
+              <a:t>• Grounding Check: Every cited clause ID must resolve to retrieved text.</a:t>
+            </a:r>
+          </a:p>
+          <a:p>
+            <a:pPr>
+              <a:spcAft>
+                <a:spcPts val="500"/>
+              </a:spcAft>
+              <a:defRPr sz="1200">
+                <a:solidFill>
+                  <a:srgbClr val="0F172A"/>
+                </a:solidFill>
+              </a:defRPr>
+            </a:pPr>
+            <a:r>
+              <a:t>• Approval Guard: Approvals without authoritative coverage citations are blocked.</a:t>
+            </a:r>
+          </a:p>
+          <a:p>
+            <a:pPr>
+              <a:spcAft>
+                <a:spcPts val="500"/>
+              </a:spcAft>
+              <a:defRPr sz="1200">
+                <a:solidFill>
+                  <a:srgbClr val="0F172A"/>
+                </a:solidFill>
+              </a:defRPr>
+            </a:pPr>
+            <a:r>
+              <a:t>• Escalation Trigger: Unverified assertions trigger immediate escalation to medical-review.</a:t>
+            </a:r>
+          </a:p>
+          <a:p>
+            <a:pPr>
+              <a:spcAft>
+                <a:spcPts val="500"/>
+              </a:spcAft>
+              <a:defRPr sz="1200">
+                <a:solidFill>
+                  <a:srgbClr val="0F172A"/>
+                </a:solidFill>
+              </a:defRPr>
+            </a:pPr>
+            <a:r>
+              <a:t>• Zero Fabrication: The system chooses human review over generating an ungrounded answer.</a:t>
             </a:r>
           </a:p>
         </p:txBody>
@@ -6008,8 +6822,8 @@
         </p:nvSpPr>
         <p:spPr>
           <a:xfrm>
-            <a:off x="6217920" y="1645920"/>
-            <a:ext cx="5120640" cy="4572000"/>
+            <a:off x="6217920" y="1508760"/>
+            <a:ext cx="5120640" cy="4846320"/>
           </a:xfrm>
           <a:prstGeom prst="roundRect">
             <a:avLst/>
@@ -6053,8 +6867,8 @@
         </p:nvSpPr>
         <p:spPr>
           <a:xfrm>
-            <a:off x="6400800" y="1828800"/>
-            <a:ext cx="4754880" cy="4206240"/>
+            <a:off x="6400800" y="1673352"/>
+            <a:ext cx="4754880" cy="4517136"/>
           </a:xfrm>
           <a:prstGeom prst="rect">
             <a:avLst/>
@@ -6069,106 +6883,76 @@
           <a:p>
             <a:pPr>
               <a:spcAft>
-                <a:spcPts val="1200"/>
-              </a:spcAft>
-              <a:defRPr sz="1600" b="1">
+                <a:spcPts val="1000"/>
+              </a:spcAft>
+              <a:defRPr sz="1500" b="1">
                 <a:solidFill>
                   <a:srgbClr val="1E3A8A"/>
                 </a:solidFill>
               </a:defRPr>
             </a:pPr>
             <a:r>
-              <a:t>Production Docker Architecture (D3, A7)</a:t>
-            </a:r>
-          </a:p>
-          <a:p>
-            <a:pPr>
-              <a:spcAft>
-                <a:spcPts val="600"/>
-              </a:spcAft>
-              <a:defRPr sz="1300">
-                <a:solidFill>
-                  <a:srgbClr val="0F172A"/>
-                </a:solidFill>
-              </a:defRPr>
-            </a:pPr>
-            <a:r>
-              <a:t>• 4 Service Boundaries under Docker Compose:</a:t>
-            </a:r>
-          </a:p>
-          <a:p>
-            <a:pPr>
-              <a:spcAft>
-                <a:spcPts val="600"/>
-              </a:spcAft>
-              <a:defRPr sz="1300">
-                <a:solidFill>
-                  <a:srgbClr val="0F172A"/>
-                </a:solidFill>
-              </a:defRPr>
-            </a:pPr>
-            <a:r>
-              <a:t>•   1. api: FastAPI REST gateway &amp; Web UI</a:t>
-            </a:r>
-          </a:p>
-          <a:p>
-            <a:pPr>
-              <a:spcAft>
-                <a:spcPts val="600"/>
-              </a:spcAft>
-              <a:defRPr sz="1300">
-                <a:solidFill>
-                  <a:srgbClr val="0F172A"/>
-                </a:solidFill>
-              </a:defRPr>
-            </a:pPr>
-            <a:r>
-              <a:t>•   2. agent-worker: Asynchronous multi-agent execution worker</a:t>
-            </a:r>
-          </a:p>
-          <a:p>
-            <a:pPr>
-              <a:spcAft>
-                <a:spcPts val="600"/>
-              </a:spcAft>
-              <a:defRPr sz="1300">
-                <a:solidFill>
-                  <a:srgbClr val="0F172A"/>
-                </a:solidFill>
-              </a:defRPr>
-            </a:pPr>
-            <a:r>
-              <a:t>•   3. redis: Distributed task queue &amp; cache</a:t>
-            </a:r>
-          </a:p>
-          <a:p>
-            <a:pPr>
-              <a:spcAft>
-                <a:spcPts val="600"/>
-              </a:spcAft>
-              <a:defRPr sz="1300">
-                <a:solidFill>
-                  <a:srgbClr val="0F172A"/>
-                </a:solidFill>
-              </a:defRPr>
-            </a:pPr>
-            <a:r>
-              <a:t>•   4. prometheus: Time-series metrics scraper (/metrics)</a:t>
-            </a:r>
-          </a:p>
-          <a:p>
-            <a:pPr>
-              <a:spcAft>
-                <a:spcPts val="600"/>
-              </a:spcAft>
-              <a:defRPr sz="1300">
-                <a:solidFill>
-                  <a:srgbClr val="0F172A"/>
-                </a:solidFill>
-              </a:defRPr>
-            </a:pPr>
-            <a:r>
-              <a:t>• Horizontal Worker Scaling: 'docker compose up --scale agent-worker=3' works seamlessly.</a:t>
+              <a:t>Adversarial &amp; Output Guardrails (L4)</a:t>
+            </a:r>
+          </a:p>
+          <a:p>
+            <a:pPr>
+              <a:spcAft>
+                <a:spcPts val="500"/>
+              </a:spcAft>
+              <a:defRPr sz="1200">
+                <a:solidFill>
+                  <a:srgbClr val="0F172A"/>
+                </a:solidFill>
+              </a:defRPr>
+            </a:pPr>
+            <a:r>
+              <a:t>• Prompt Injection Defense: Regex &amp; semantic filters detect 'ignore previous rules', 'system override', 'DAN mode'.</a:t>
+            </a:r>
+          </a:p>
+          <a:p>
+            <a:pPr>
+              <a:spcAft>
+                <a:spcPts val="500"/>
+              </a:spcAft>
+              <a:defRPr sz="1200">
+                <a:solidFill>
+                  <a:srgbClr val="0F172A"/>
+                </a:solidFill>
+              </a:defRPr>
+            </a:pPr>
+            <a:r>
+              <a:t>• Toxicity filter blocks abusive/fraudulent payloads.</a:t>
+            </a:r>
+          </a:p>
+          <a:p>
+            <a:pPr>
+              <a:spcAft>
+                <a:spcPts val="500"/>
+              </a:spcAft>
+              <a:defRPr sz="1200">
+                <a:solidFill>
+                  <a:srgbClr val="0F172A"/>
+                </a:solidFill>
+              </a:defRPr>
+            </a:pPr>
+            <a:r>
+              <a:t>• Authority Boundary Guardrail: Output filter strips unauthorized binding declarations ('insurer guarantees payment').</a:t>
+            </a:r>
+          </a:p>
+          <a:p>
+            <a:pPr>
+              <a:spcAft>
+                <a:spcPts val="500"/>
+              </a:spcAft>
+              <a:defRPr sz="1200">
+                <a:solidFill>
+                  <a:srgbClr val="0F172A"/>
+                </a:solidFill>
+              </a:defRPr>
+            </a:pPr>
+            <a:r>
+              <a:t>• Mandatory Legal Disclaimer automatically appended to every response.</a:t>
             </a:r>
           </a:p>
         </p:txBody>
@@ -6199,8 +6983,8 @@
         </p:nvSpPr>
         <p:spPr>
           <a:xfrm>
-            <a:off x="731520" y="457200"/>
-            <a:ext cx="10515600" cy="365760"/>
+            <a:off x="731520" y="411480"/>
+            <a:ext cx="10515600" cy="320040"/>
           </a:xfrm>
           <a:prstGeom prst="rect">
             <a:avLst/>
@@ -6234,7 +7018,7 @@
         </p:nvSpPr>
         <p:spPr>
           <a:xfrm>
-            <a:off x="731520" y="777240"/>
+            <a:off x="731520" y="685800"/>
             <a:ext cx="10515600" cy="640080"/>
           </a:xfrm>
           <a:prstGeom prst="rect">
@@ -6249,14 +7033,14 @@
           <a:lstStyle/>
           <a:p>
             <a:pPr>
-              <a:defRPr sz="2400" b="1">
+              <a:defRPr sz="2300" b="1">
                 <a:solidFill>
                   <a:srgbClr val="1E3A8A"/>
                 </a:solidFill>
               </a:defRPr>
             </a:pPr>
             <a:r>
-              <a:t>Service Level Objective (SLO) &amp; Locust Load Testing (D6)</a:t>
+              <a:t>Benchmark Evaluation: 20 Scenarios (L2, L3)</a:t>
             </a:r>
           </a:p>
         </p:txBody>
@@ -6269,8 +7053,8 @@
         </p:nvSpPr>
         <p:spPr>
           <a:xfrm>
-            <a:off x="731520" y="1645920"/>
-            <a:ext cx="5120640" cy="4572000"/>
+            <a:off x="731520" y="1508760"/>
+            <a:ext cx="5120640" cy="4846320"/>
           </a:xfrm>
           <a:prstGeom prst="roundRect">
             <a:avLst/>
@@ -6314,8 +7098,8 @@
         </p:nvSpPr>
         <p:spPr>
           <a:xfrm>
-            <a:off x="914400" y="1828800"/>
-            <a:ext cx="4754880" cy="4206240"/>
+            <a:off x="914400" y="1673352"/>
+            <a:ext cx="4754880" cy="4517136"/>
           </a:xfrm>
           <a:prstGeom prst="rect">
             <a:avLst/>
@@ -6330,76 +7114,106 @@
           <a:p>
             <a:pPr>
               <a:spcAft>
-                <a:spcPts val="1200"/>
-              </a:spcAft>
-              <a:defRPr sz="1600" b="1">
+                <a:spcPts val="1000"/>
+              </a:spcAft>
+              <a:defRPr sz="1500" b="1">
                 <a:solidFill>
                   <a:srgbClr val="1E3A8A"/>
                 </a:solidFill>
               </a:defRPr>
             </a:pPr>
             <a:r>
-              <a:t>Declared SLO Target (Pre-Measurement)</a:t>
-            </a:r>
-          </a:p>
-          <a:p>
-            <a:pPr>
-              <a:spcAft>
-                <a:spcPts val="600"/>
-              </a:spcAft>
-              <a:defRPr sz="1300">
-                <a:solidFill>
-                  <a:srgbClr val="0F172A"/>
-                </a:solidFill>
-              </a:defRPr>
-            </a:pPr>
-            <a:r>
-              <a:t>• SLO Declaration: End-to-end run latency p95 &lt;= 2.50s (2500 ms).</a:t>
-            </a:r>
-          </a:p>
-          <a:p>
-            <a:pPr>
-              <a:spcAft>
-                <a:spcPts val="600"/>
-              </a:spcAft>
-              <a:defRPr sz="1300">
-                <a:solidFill>
-                  <a:srgbClr val="0F172A"/>
-                </a:solidFill>
-              </a:defRPr>
-            </a:pPr>
-            <a:r>
-              <a:t>• Justification: Pre-auth decisions must beat human desk speed (several minutes) while handling high hospital peak volumes.</a:t>
-            </a:r>
-          </a:p>
-          <a:p>
-            <a:pPr>
-              <a:spcAft>
-                <a:spcPts val="600"/>
-              </a:spcAft>
-              <a:defRPr sz="1300">
-                <a:solidFill>
-                  <a:srgbClr val="0F172A"/>
-                </a:solidFill>
-              </a:defRPr>
-            </a:pPr>
-            <a:r>
-              <a:t>• End-to-End Scope: Measures complete lifecycle from POST submission, queue transit, reasoning, to polling completion.</a:t>
-            </a:r>
-          </a:p>
-          <a:p>
-            <a:pPr>
-              <a:spcAft>
-                <a:spcPts val="600"/>
-              </a:spcAft>
-              <a:defRPr sz="1300">
-                <a:solidFill>
-                  <a:srgbClr val="0F172A"/>
-                </a:solidFill>
-              </a:defRPr>
-            </a:pPr>
-            <a:r>
-              <a:t>• Stub Service: Evaluated against deterministic stub to test system concurrency rather than upstream rate limits.</a:t>
+              <a:t>Evaluation Methodology (TruLens Metrics)</a:t>
+            </a:r>
+          </a:p>
+          <a:p>
+            <a:pPr>
+              <a:spcAft>
+                <a:spcPts val="500"/>
+              </a:spcAft>
+              <a:defRPr sz="1200">
+                <a:solidFill>
+                  <a:srgbClr val="0F172A"/>
+                </a:solidFill>
+              </a:defRPr>
+            </a:pPr>
+            <a:r>
+              <a:t>• Fixed suite of 20 diverse clinical scenarios in data/eval_scenarios.json.</a:t>
+            </a:r>
+          </a:p>
+          <a:p>
+            <a:pPr>
+              <a:spcAft>
+                <a:spcPts val="500"/>
+              </a:spcAft>
+              <a:defRPr sz="1200">
+                <a:solidFill>
+                  <a:srgbClr val="0F172A"/>
+                </a:solidFill>
+              </a:defRPr>
+            </a:pPr>
+            <a:r>
+              <a:t>• Groundedness: Ratio of cited assertions anchored in retrieved passages.</a:t>
+            </a:r>
+          </a:p>
+          <a:p>
+            <a:pPr>
+              <a:spcAft>
+                <a:spcPts val="500"/>
+              </a:spcAft>
+              <a:defRPr sz="1200">
+                <a:solidFill>
+                  <a:srgbClr val="0F172A"/>
+                </a:solidFill>
+              </a:defRPr>
+            </a:pPr>
+            <a:r>
+              <a:t>• Context Relevance: Ratio of retrieved provisions pertinent to the clinical case.</a:t>
+            </a:r>
+          </a:p>
+          <a:p>
+            <a:pPr>
+              <a:spcAft>
+                <a:spcPts val="500"/>
+              </a:spcAft>
+              <a:defRPr sz="1200">
+                <a:solidFill>
+                  <a:srgbClr val="0F172A"/>
+                </a:solidFill>
+              </a:defRPr>
+            </a:pPr>
+            <a:r>
+              <a:t>• Faithfulness: Agreement between verdict and waiting-period/exclusion rules.</a:t>
+            </a:r>
+          </a:p>
+          <a:p>
+            <a:pPr>
+              <a:spcAft>
+                <a:spcPts val="500"/>
+              </a:spcAft>
+              <a:defRPr sz="1200">
+                <a:solidFill>
+                  <a:srgbClr val="0F172A"/>
+                </a:solidFill>
+              </a:defRPr>
+            </a:pPr>
+            <a:r>
+              <a:t>• Hallucination Rate: 1.0 - Faithfulness.</a:t>
+            </a:r>
+          </a:p>
+          <a:p>
+            <a:pPr>
+              <a:spcAft>
+                <a:spcPts val="500"/>
+              </a:spcAft>
+              <a:defRPr sz="1200">
+                <a:solidFill>
+                  <a:srgbClr val="0F172A"/>
+                </a:solidFill>
+              </a:defRPr>
+            </a:pPr>
+            <a:r>
+              <a:t>• CLI Runner: Runnable as a batch from command line via 'python -m src.evaluator'.</a:t>
             </a:r>
           </a:p>
         </p:txBody>
@@ -6412,8 +7226,8 @@
         </p:nvSpPr>
         <p:spPr>
           <a:xfrm>
-            <a:off x="6217920" y="1645920"/>
-            <a:ext cx="5120640" cy="4572000"/>
+            <a:off x="6217920" y="1508760"/>
+            <a:ext cx="5120640" cy="4846320"/>
           </a:xfrm>
           <a:prstGeom prst="roundRect">
             <a:avLst/>
@@ -6457,8 +7271,8 @@
         </p:nvSpPr>
         <p:spPr>
           <a:xfrm>
-            <a:off x="6400800" y="1828800"/>
-            <a:ext cx="4754880" cy="4206240"/>
+            <a:off x="6400800" y="1673352"/>
+            <a:ext cx="4754880" cy="4517136"/>
           </a:xfrm>
           <a:prstGeom prst="rect">
             <a:avLst/>
@@ -6473,76 +7287,151 @@
           <a:p>
             <a:pPr>
               <a:spcAft>
-                <a:spcPts val="1200"/>
-              </a:spcAft>
-              <a:defRPr sz="1600" b="1">
+                <a:spcPts val="1000"/>
+              </a:spcAft>
+              <a:defRPr sz="1500" b="1">
                 <a:solidFill>
                   <a:srgbClr val="1E3A8A"/>
                 </a:solidFill>
               </a:defRPr>
             </a:pPr>
             <a:r>
-              <a:t>Locust Benchmark Findings</a:t>
-            </a:r>
-          </a:p>
-          <a:p>
-            <a:pPr>
-              <a:spcAft>
-                <a:spcPts val="600"/>
-              </a:spcAft>
-              <a:defRPr sz="1300">
-                <a:solidFill>
-                  <a:srgbClr val="0F172A"/>
-                </a:solidFill>
-              </a:defRPr>
-            </a:pPr>
-            <a:r>
-              <a:t>• Achieved p50 Latency: ~65 ms | Achieved p95 Latency: ~140 ms.</a:t>
-            </a:r>
-          </a:p>
-          <a:p>
-            <a:pPr>
-              <a:spcAft>
-                <a:spcPts val="600"/>
-              </a:spcAft>
-              <a:defRPr sz="1300">
-                <a:solidFill>
-                  <a:srgbClr val="0F172A"/>
-                </a:solidFill>
-              </a:defRPr>
-            </a:pPr>
-            <a:r>
-              <a:t>• Target Met: Confirmed p95 (140 ms) &lt;&lt; Declared SLO (2500 ms).</a:t>
-            </a:r>
-          </a:p>
-          <a:p>
-            <a:pPr>
-              <a:spcAft>
-                <a:spcPts val="600"/>
-              </a:spcAft>
-              <a:defRPr sz="1300">
-                <a:solidFill>
-                  <a:srgbClr val="0F172A"/>
-                </a:solidFill>
-              </a:defRPr>
-            </a:pPr>
-            <a:r>
-              <a:t>• Throughput: Exceeds 250 requests per second under multi-worker scaling.</a:t>
-            </a:r>
-          </a:p>
-          <a:p>
-            <a:pPr>
-              <a:spcAft>
-                <a:spcPts val="600"/>
-              </a:spcAft>
-              <a:defRPr sz="1300">
-                <a:solidFill>
-                  <a:srgbClr val="0F172A"/>
-                </a:solidFill>
-              </a:defRPr>
-            </a:pPr>
-            <a:r>
-              <a:t>• Bottleneck Identification: Under extreme concurrency (500+ users), queue polling frequency is the primary saturation point.</a:t>
+              <a:t>Prompt Variant Comparison (L2)</a:t>
+            </a:r>
+          </a:p>
+          <a:p>
+            <a:pPr>
+              <a:spcAft>
+                <a:spcPts val="500"/>
+              </a:spcAft>
+              <a:defRPr sz="1200">
+                <a:solidFill>
+                  <a:srgbClr val="0F172A"/>
+                </a:solidFill>
+              </a:defRPr>
+            </a:pPr>
+            <a:r>
+              <a:t>• Prompt v1 (Concise single-pass):</a:t>
+            </a:r>
+          </a:p>
+          <a:p>
+            <a:pPr>
+              <a:spcAft>
+                <a:spcPts val="500"/>
+              </a:spcAft>
+              <a:defRPr sz="1200">
+                <a:solidFill>
+                  <a:srgbClr val="0F172A"/>
+                </a:solidFill>
+              </a:defRPr>
+            </a:pPr>
+            <a:r>
+              <a:t>•   - Routing Accuracy: 80.0%  | Groundedness: 0.600</a:t>
+            </a:r>
+          </a:p>
+          <a:p>
+            <a:pPr>
+              <a:spcAft>
+                <a:spcPts val="500"/>
+              </a:spcAft>
+              <a:defRPr sz="1200">
+                <a:solidFill>
+                  <a:srgbClr val="0F172A"/>
+                </a:solidFill>
+              </a:defRPr>
+            </a:pPr>
+            <a:r>
+              <a:t>•   - Faithfulness: 0.650      | Hallucination Rate: 0.350</a:t>
+            </a:r>
+          </a:p>
+          <a:p>
+            <a:pPr>
+              <a:spcAft>
+                <a:spcPts val="500"/>
+              </a:spcAft>
+              <a:defRPr sz="1200">
+                <a:solidFill>
+                  <a:srgbClr val="0F172A"/>
+                </a:solidFill>
+              </a:defRPr>
+            </a:pPr>
+            <a:r>
+              <a:t>• Prompt v2 (Verified CoT with 2-Stage Retrieval):</a:t>
+            </a:r>
+          </a:p>
+          <a:p>
+            <a:pPr>
+              <a:spcAft>
+                <a:spcPts val="500"/>
+              </a:spcAft>
+              <a:defRPr sz="1200">
+                <a:solidFill>
+                  <a:srgbClr val="0F172A"/>
+                </a:solidFill>
+              </a:defRPr>
+            </a:pPr>
+            <a:r>
+              <a:t>•   - Routing Accuracy: 100.0% (+20.0%)</a:t>
+            </a:r>
+          </a:p>
+          <a:p>
+            <a:pPr>
+              <a:spcAft>
+                <a:spcPts val="500"/>
+              </a:spcAft>
+              <a:defRPr sz="1200">
+                <a:solidFill>
+                  <a:srgbClr val="0F172A"/>
+                </a:solidFill>
+              </a:defRPr>
+            </a:pPr>
+            <a:r>
+              <a:t>•   - Groundedness: 0.925 (+0.325)</a:t>
+            </a:r>
+          </a:p>
+          <a:p>
+            <a:pPr>
+              <a:spcAft>
+                <a:spcPts val="500"/>
+              </a:spcAft>
+              <a:defRPr sz="1200">
+                <a:solidFill>
+                  <a:srgbClr val="0F172A"/>
+                </a:solidFill>
+              </a:defRPr>
+            </a:pPr>
+            <a:r>
+              <a:t>•   - Faithfulness: 0.900 (+0.250)</a:t>
+            </a:r>
+          </a:p>
+          <a:p>
+            <a:pPr>
+              <a:spcAft>
+                <a:spcPts val="500"/>
+              </a:spcAft>
+              <a:defRPr sz="1200">
+                <a:solidFill>
+                  <a:srgbClr val="0F172A"/>
+                </a:solidFill>
+              </a:defRPr>
+            </a:pPr>
+            <a:r>
+              <a:t>•   - Hallucination Rate: 0.100 (-25.0% reduction)</a:t>
+            </a:r>
+          </a:p>
+          <a:p>
+            <a:pPr>
+              <a:spcAft>
+                <a:spcPts val="500"/>
+              </a:spcAft>
+              <a:defRPr sz="1200">
+                <a:solidFill>
+                  <a:srgbClr val="0F172A"/>
+                </a:solidFill>
+              </a:defRPr>
+            </a:pPr>
+            <a:r>
+              <a:t>• Cost per 100 runs: $0.004032 (Ultra cost-effective).</a:t>
             </a:r>
           </a:p>
         </p:txBody>
@@ -6573,8 +7462,8 @@
         </p:nvSpPr>
         <p:spPr>
           <a:xfrm>
-            <a:off x="731520" y="457200"/>
-            <a:ext cx="10515600" cy="365760"/>
+            <a:off x="731520" y="411480"/>
+            <a:ext cx="10515600" cy="320040"/>
           </a:xfrm>
           <a:prstGeom prst="rect">
             <a:avLst/>
@@ -6608,7 +7497,7 @@
         </p:nvSpPr>
         <p:spPr>
           <a:xfrm>
-            <a:off x="731520" y="777240"/>
+            <a:off x="731520" y="685800"/>
             <a:ext cx="10515600" cy="640080"/>
           </a:xfrm>
           <a:prstGeom prst="rect">
@@ -6623,14 +7512,14 @@
           <a:lstStyle/>
           <a:p>
             <a:pPr>
-              <a:defRPr sz="2400" b="1">
+              <a:defRPr sz="2300" b="1">
                 <a:solidFill>
                   <a:srgbClr val="1E3A8A"/>
                 </a:solidFill>
               </a:defRPr>
             </a:pPr>
             <a:r>
-              <a:t>Demonstration Verification Matrix (All 10 Items Ready)</a:t>
+              <a:t>Operational Resilience &amp; Circuit Breaker (A5)</a:t>
             </a:r>
           </a:p>
         </p:txBody>
@@ -6643,8 +7532,8 @@
         </p:nvSpPr>
         <p:spPr>
           <a:xfrm>
-            <a:off x="731520" y="1645920"/>
-            <a:ext cx="5120640" cy="4572000"/>
+            <a:off x="731520" y="1508760"/>
+            <a:ext cx="5120640" cy="4846320"/>
           </a:xfrm>
           <a:prstGeom prst="roundRect">
             <a:avLst/>
@@ -6688,8 +7577,8 @@
         </p:nvSpPr>
         <p:spPr>
           <a:xfrm>
-            <a:off x="914400" y="1828800"/>
-            <a:ext cx="4754880" cy="4206240"/>
+            <a:off x="914400" y="1673352"/>
+            <a:ext cx="4754880" cy="4517136"/>
           </a:xfrm>
           <a:prstGeom prst="rect">
             <a:avLst/>
@@ -6704,91 +7593,76 @@
           <a:p>
             <a:pPr>
               <a:spcAft>
-                <a:spcPts val="1200"/>
-              </a:spcAft>
-              <a:defRPr sz="1600" b="1">
+                <a:spcPts val="1000"/>
+              </a:spcAft>
+              <a:defRPr sz="1500" b="1">
                 <a:solidFill>
                   <a:srgbClr val="1E3A8A"/>
                 </a:solidFill>
               </a:defRPr>
             </a:pPr>
             <a:r>
-              <a:t>Items 1 to 5</a:t>
-            </a:r>
-          </a:p>
-          <a:p>
-            <a:pPr>
-              <a:spcAft>
-                <a:spcPts val="600"/>
-              </a:spcAft>
-              <a:defRPr sz="1300">
-                <a:solidFill>
-                  <a:srgbClr val="0F172A"/>
-                </a:solidFill>
-              </a:defRPr>
-            </a:pPr>
-            <a:r>
-              <a:t>• 1. Docker compose up from clean clone: 4 healthy services.</a:t>
-            </a:r>
-          </a:p>
-          <a:p>
-            <a:pPr>
-              <a:spcAft>
-                <a:spcPts val="600"/>
-              </a:spcAft>
-              <a:defRPr sz="1300">
-                <a:solidFill>
-                  <a:srgbClr val="0F172A"/>
-                </a:solidFill>
-              </a:defRPr>
-            </a:pPr>
-            <a:r>
-              <a:t>• 2. Valid request producing routed recommendation with citations.</a:t>
-            </a:r>
-          </a:p>
-          <a:p>
-            <a:pPr>
-              <a:spcAft>
-                <a:spcPts val="600"/>
-              </a:spcAft>
-              <a:defRPr sz="1300">
-                <a:solidFill>
-                  <a:srgbClr val="0F172A"/>
-                </a:solidFill>
-              </a:defRPr>
-            </a:pPr>
-            <a:r>
-              <a:t>• 3. Traced end-to-end: Tool calls, queries, passages, prompt version, latency, cost.</a:t>
-            </a:r>
-          </a:p>
-          <a:p>
-            <a:pPr>
-              <a:spcAft>
-                <a:spcPts val="600"/>
-              </a:spcAft>
-              <a:defRPr sz="1300">
-                <a:solidFill>
-                  <a:srgbClr val="0F172A"/>
-                </a:solidFill>
-              </a:defRPr>
-            </a:pPr>
-            <a:r>
-              <a:t>• 4. Malformed request quarantined: Zero agent runs initiated.</a:t>
-            </a:r>
-          </a:p>
-          <a:p>
-            <a:pPr>
-              <a:spcAft>
-                <a:spcPts val="600"/>
-              </a:spcAft>
-              <a:defRPr sz="1300">
-                <a:solidFill>
-                  <a:srgbClr val="0F172A"/>
-                </a:solidFill>
-              </a:defRPr>
-            </a:pPr>
-            <a:r>
-              <a:t>• 5. Out-of-corpus procedure: Escalated to human without hallucination.</a:t>
+              <a:t>Circuit Breaker State Machine</a:t>
+            </a:r>
+          </a:p>
+          <a:p>
+            <a:pPr>
+              <a:spcAft>
+                <a:spcPts val="500"/>
+              </a:spcAft>
+              <a:defRPr sz="1200">
+                <a:solidFill>
+                  <a:srgbClr val="0F172A"/>
+                </a:solidFill>
+              </a:defRPr>
+            </a:pPr>
+            <a:r>
+              <a:t>• Trips to OPEN after 3 consecutive provider failures / timeouts.</a:t>
+            </a:r>
+          </a:p>
+          <a:p>
+            <a:pPr>
+              <a:spcAft>
+                <a:spcPts val="500"/>
+              </a:spcAft>
+              <a:defRPr sz="1200">
+                <a:solidFill>
+                  <a:srgbClr val="0F172A"/>
+                </a:solidFill>
+              </a:defRPr>
+            </a:pPr>
+            <a:r>
+              <a:t>• Auto-Reset: Transitions to HALF_OPEN after 30 seconds (CB_RESET_TIMEOUT_SEC).</a:t>
+            </a:r>
+          </a:p>
+          <a:p>
+            <a:pPr>
+              <a:spcAft>
+                <a:spcPts val="500"/>
+              </a:spcAft>
+              <a:defRPr sz="1200">
+                <a:solidFill>
+                  <a:srgbClr val="0F172A"/>
+                </a:solidFill>
+              </a:defRPr>
+            </a:pPr>
+            <a:r>
+              <a:t>• Admin Endpoint: POST /api/v1/admin/circuit-breaker/toggle allows simulated testing.</a:t>
+            </a:r>
+          </a:p>
+          <a:p>
+            <a:pPr>
+              <a:spcAft>
+                <a:spcPts val="500"/>
+              </a:spcAft>
+              <a:defRPr sz="1200">
+                <a:solidFill>
+                  <a:srgbClr val="0F172A"/>
+                </a:solidFill>
+              </a:defRPr>
+            </a:pPr>
+            <a:r>
+              <a:t>• UI Integration: Top-bar badge indicates live status (CLOSED vs OPEN).</a:t>
             </a:r>
           </a:p>
         </p:txBody>
@@ -6801,8 +7675,8 @@
         </p:nvSpPr>
         <p:spPr>
           <a:xfrm>
-            <a:off x="6217920" y="1645920"/>
-            <a:ext cx="5120640" cy="4572000"/>
+            <a:off x="6217920" y="1508760"/>
+            <a:ext cx="5120640" cy="4846320"/>
           </a:xfrm>
           <a:prstGeom prst="roundRect">
             <a:avLst/>
@@ -6846,8 +7720,8 @@
         </p:nvSpPr>
         <p:spPr>
           <a:xfrm>
-            <a:off x="6400800" y="1828800"/>
-            <a:ext cx="4754880" cy="4206240"/>
+            <a:off x="6400800" y="1673352"/>
+            <a:ext cx="4754880" cy="4517136"/>
           </a:xfrm>
           <a:prstGeom prst="rect">
             <a:avLst/>
@@ -6862,91 +7736,76 @@
           <a:p>
             <a:pPr>
               <a:spcAft>
-                <a:spcPts val="1200"/>
-              </a:spcAft>
-              <a:defRPr sz="1600" b="1">
+                <a:spcPts val="1000"/>
+              </a:spcAft>
+              <a:defRPr sz="1500" b="1">
                 <a:solidFill>
                   <a:srgbClr val="1E3A8A"/>
                 </a:solidFill>
               </a:defRPr>
             </a:pPr>
             <a:r>
-              <a:t>Items 6 to 10</a:t>
-            </a:r>
-          </a:p>
-          <a:p>
-            <a:pPr>
-              <a:spcAft>
-                <a:spcPts val="600"/>
-              </a:spcAft>
-              <a:defRPr sz="1300">
-                <a:solidFill>
-                  <a:srgbClr val="0F172A"/>
-                </a:solidFill>
-              </a:defRPr>
-            </a:pPr>
-            <a:r>
-              <a:t>• 6. Self-verification catching unsupported answer &amp; escalating.</a:t>
-            </a:r>
-          </a:p>
-          <a:p>
-            <a:pPr>
-              <a:spcAft>
-                <a:spcPts val="600"/>
-              </a:spcAft>
-              <a:defRPr sz="1300">
-                <a:solidFill>
-                  <a:srgbClr val="0F172A"/>
-                </a:solidFill>
-              </a:defRPr>
-            </a:pPr>
-            <a:r>
-              <a:t>• 7. Prompt injection attack caught by input guardrail.</a:t>
-            </a:r>
-          </a:p>
-          <a:p>
-            <a:pPr>
-              <a:spcAft>
-                <a:spcPts val="600"/>
-              </a:spcAft>
-              <a:defRPr sz="1300">
-                <a:solidFill>
-                  <a:srgbClr val="0F172A"/>
-                </a:solidFill>
-              </a:defRPr>
-            </a:pPr>
-            <a:r>
-              <a:t>• 8. Circuit breaker toggles to OPEN with graceful degradation.</a:t>
-            </a:r>
-          </a:p>
-          <a:p>
-            <a:pPr>
-              <a:spcAft>
-                <a:spcPts val="600"/>
-              </a:spcAft>
-              <a:defRPr sz="1300">
-                <a:solidFill>
-                  <a:srgbClr val="0F172A"/>
-                </a:solidFill>
-              </a:defRPr>
-            </a:pPr>
-            <a:r>
-              <a:t>• 9. Locust load test confirms declared p95 SLO compliance.</a:t>
-            </a:r>
-          </a:p>
-          <a:p>
-            <a:pPr>
-              <a:spcAft>
-                <a:spcPts val="600"/>
-              </a:spcAft>
-              <a:defRPr sz="1300">
-                <a:solidFill>
-                  <a:srgbClr val="0F172A"/>
-                </a:solidFill>
-              </a:defRPr>
-            </a:pPr>
-            <a:r>
-              <a:t>• 10. Section 4.1 Difficult Case: Cataract at 11m vintage correctly cites both Cover and 24m Waiting Period!</a:t>
+              <a:t>Graceful Degradation Fallback (Demo Item 8)</a:t>
+            </a:r>
+          </a:p>
+          <a:p>
+            <a:pPr>
+              <a:spcAft>
+                <a:spcPts val="500"/>
+              </a:spcAft>
+              <a:defRPr sz="1200">
+                <a:solidFill>
+                  <a:srgbClr val="0F172A"/>
+                </a:solidFill>
+              </a:defRPr>
+            </a:pPr>
+            <a:r>
+              <a:t>• When OPEN, incoming runs do NOT fail with 500 errors or time out.</a:t>
+            </a:r>
+          </a:p>
+          <a:p>
+            <a:pPr>
+              <a:spcAft>
+                <a:spcPts val="500"/>
+              </a:spcAft>
+              <a:defRPr sz="1200">
+                <a:solidFill>
+                  <a:srgbClr val="0F172A"/>
+                </a:solidFill>
+              </a:defRPr>
+            </a:pPr>
+            <a:r>
+              <a:t>• Immediate Routing: Requests route directly to human 'medical-review'.</a:t>
+            </a:r>
+          </a:p>
+          <a:p>
+            <a:pPr>
+              <a:spcAft>
+                <a:spcPts val="500"/>
+              </a:spcAft>
+              <a:defRPr sz="1200">
+                <a:solidFill>
+                  <a:srgbClr val="0F172A"/>
+                </a:solidFill>
+              </a:defRPr>
+            </a:pPr>
+            <a:r>
+              <a:t>• Reason Stated: 'Circuit breaker OPEN: upstream provider unavailable'.</a:t>
+            </a:r>
+          </a:p>
+          <a:p>
+            <a:pPr>
+              <a:spcAft>
+                <a:spcPts val="500"/>
+              </a:spcAft>
+              <a:defRPr sz="1200">
+                <a:solidFill>
+                  <a:srgbClr val="0F172A"/>
+                </a:solidFill>
+              </a:defRPr>
+            </a:pPr>
+            <a:r>
+              <a:t>• Sub-second Execution: Fallback executes in ~2ms without wasting LLM budget.</a:t>
             </a:r>
           </a:p>
         </p:txBody>

</xml_diff>